<commit_message>
update slides and paper sakelaton
</commit_message>
<xml_diff>
--- a/docs/meeting/2026_08_05.pptx
+++ b/docs/meeting/2026_08_05.pptx
@@ -5,7 +5,7 @@
     <p:sldMasterId id="2147483648" r:id="rId1"/>
   </p:sldMasterIdLst>
   <p:notesMasterIdLst>
-    <p:notesMasterId r:id="rId30"/>
+    <p:notesMasterId r:id="rId28"/>
   </p:notesMasterIdLst>
   <p:sldIdLst>
     <p:sldId id="1574" r:id="rId2"/>
@@ -31,11 +31,9 @@
     <p:sldId id="1774" r:id="rId22"/>
     <p:sldId id="1729" r:id="rId23"/>
     <p:sldId id="1730" r:id="rId24"/>
-    <p:sldId id="1767" r:id="rId25"/>
-    <p:sldId id="1782" r:id="rId26"/>
-    <p:sldId id="1777" r:id="rId27"/>
-    <p:sldId id="1778" r:id="rId28"/>
-    <p:sldId id="1779" r:id="rId29"/>
+    <p:sldId id="1788" r:id="rId25"/>
+    <p:sldId id="1767" r:id="rId26"/>
+    <p:sldId id="1782" r:id="rId27"/>
   </p:sldIdLst>
   <p:sldSz cx="12192000" cy="6858000"/>
   <p:notesSz cx="6858000" cy="9144000"/>
@@ -166,11 +164,9 @@
             <p14:sldId id="1774"/>
             <p14:sldId id="1729"/>
             <p14:sldId id="1730"/>
+            <p14:sldId id="1788"/>
             <p14:sldId id="1767"/>
             <p14:sldId id="1782"/>
-            <p14:sldId id="1777"/>
-            <p14:sldId id="1778"/>
-            <p14:sldId id="1779"/>
           </p14:sldIdLst>
         </p14:section>
       </p14:sectionLst>
@@ -6169,7 +6165,7 @@
           <a:p>
             <a:fld id="{2915196C-CDBC-4DEE-A220-849C85FC22AC}" type="datetimeFigureOut">
               <a:rPr lang="he-IL" smtClean="0"/>
-              <a:t>כ'/אב/תשפ"ו</a:t>
+              <a:t>כ"ב/אב/תשפ"ו</a:t>
             </a:fld>
             <a:endParaRPr lang="he-IL"/>
           </a:p>
@@ -6738,7 +6734,7 @@
           <a:p>
             <a:fld id="{FC6B3A86-AB79-4388-8CA5-9FC4B834779B}" type="datetime8">
               <a:rPr lang="he-IL" smtClean="0"/>
-              <a:t>03 אוגוסט 26</a:t>
+              <a:t>05 אוגוסט 26</a:t>
             </a:fld>
             <a:endParaRPr lang="he-IL"/>
           </a:p>
@@ -6961,7 +6957,7 @@
           <a:p>
             <a:fld id="{18F56BC8-8E7D-4896-9980-77BC87FB8E3E}" type="datetime8">
               <a:rPr lang="he-IL" smtClean="0"/>
-              <a:t>03 אוגוסט 26</a:t>
+              <a:t>05 אוגוסט 26</a:t>
             </a:fld>
             <a:endParaRPr lang="he-IL"/>
           </a:p>
@@ -7194,7 +7190,7 @@
           <a:p>
             <a:fld id="{0FE327C8-CB36-417E-834B-544633ADCE63}" type="datetime8">
               <a:rPr lang="he-IL" smtClean="0"/>
-              <a:t>03 אוגוסט 26</a:t>
+              <a:t>05 אוגוסט 26</a:t>
             </a:fld>
             <a:endParaRPr lang="he-IL"/>
           </a:p>
@@ -7312,7 +7308,7 @@
           <a:p>
             <a:fld id="{8E065D1C-C98B-44F5-AB2A-FEE3E85D0A94}" type="datetime8">
               <a:rPr lang="he-IL" smtClean="0"/>
-              <a:t>03 אוגוסט 26</a:t>
+              <a:t>05 אוגוסט 26</a:t>
             </a:fld>
             <a:endParaRPr lang="he-IL"/>
           </a:p>
@@ -7627,7 +7623,7 @@
           <a:p>
             <a:fld id="{7634CBFB-2532-48BA-BAE2-ADD925390740}" type="datetime8">
               <a:rPr lang="he-IL" smtClean="0"/>
-              <a:t>03 אוגוסט 26</a:t>
+              <a:t>05 אוגוסט 26</a:t>
             </a:fld>
             <a:endParaRPr lang="he-IL"/>
           </a:p>
@@ -7910,7 +7906,7 @@
           <a:p>
             <a:fld id="{8EAC1FDD-37C4-4A6B-BF31-779943CE32CF}" type="datetime8">
               <a:rPr lang="he-IL" smtClean="0"/>
-              <a:t>03 אוגוסט 26</a:t>
+              <a:t>05 אוגוסט 26</a:t>
             </a:fld>
             <a:endParaRPr lang="he-IL"/>
           </a:p>
@@ -8223,7 +8219,7 @@
           <a:p>
             <a:fld id="{C73C226C-A76A-4927-8F1D-1BD4AC033ABB}" type="datetime8">
               <a:rPr lang="he-IL" smtClean="0"/>
-              <a:t>03 אוגוסט 26</a:t>
+              <a:t>05 אוגוסט 26</a:t>
             </a:fld>
             <a:endParaRPr lang="he-IL"/>
           </a:p>
@@ -8726,7 +8722,7 @@
           <a:p>
             <a:fld id="{430DF2BF-D428-43E9-B36B-6DD16CF93579}" type="datetime8">
               <a:rPr lang="he-IL" smtClean="0"/>
-              <a:t>03 אוגוסט 26</a:t>
+              <a:t>05 אוגוסט 26</a:t>
             </a:fld>
             <a:endParaRPr lang="he-IL"/>
           </a:p>
@@ -8873,7 +8869,7 @@
           <a:p>
             <a:fld id="{390A9136-4922-4C74-B05C-12CD0951E601}" type="datetime8">
               <a:rPr lang="he-IL" smtClean="0"/>
-              <a:t>03 אוגוסט 26</a:t>
+              <a:t>05 אוגוסט 26</a:t>
             </a:fld>
             <a:endParaRPr lang="he-IL"/>
           </a:p>
@@ -8991,7 +8987,7 @@
           <a:p>
             <a:fld id="{C29F3CA8-2E63-412C-AA06-0D760EBE5965}" type="datetime8">
               <a:rPr lang="he-IL" smtClean="0"/>
-              <a:t>03 אוגוסט 26</a:t>
+              <a:t>05 אוגוסט 26</a:t>
             </a:fld>
             <a:endParaRPr lang="he-IL"/>
           </a:p>
@@ -9313,7 +9309,7 @@
           <a:p>
             <a:fld id="{7AC7B867-AA4A-4FF3-AD8B-0AD0F18EE595}" type="datetime8">
               <a:rPr lang="he-IL" smtClean="0"/>
-              <a:t>03 אוגוסט 26</a:t>
+              <a:t>05 אוגוסט 26</a:t>
             </a:fld>
             <a:endParaRPr lang="he-IL"/>
           </a:p>
@@ -9611,7 +9607,7 @@
           <a:p>
             <a:fld id="{F5E9EBD3-88E8-46DB-BD3B-F935B7013014}" type="datetime8">
               <a:rPr lang="he-IL" smtClean="0"/>
-              <a:t>03 אוגוסט 26</a:t>
+              <a:t>05 אוגוסט 26</a:t>
             </a:fld>
             <a:endParaRPr lang="he-IL"/>
           </a:p>
@@ -9895,7 +9891,7 @@
           <a:p>
             <a:fld id="{8E065D1C-C98B-44F5-AB2A-FEE3E85D0A94}" type="datetime8">
               <a:rPr lang="he-IL" smtClean="0"/>
-              <a:t>03 אוגוסט 26</a:t>
+              <a:t>05 אוגוסט 26</a:t>
             </a:fld>
             <a:endParaRPr lang="he-IL"/>
           </a:p>
@@ -11824,20 +11820,24 @@
           <a:p>
             <a:pPr lvl="1"/>
             <a:r>
+              <a:rPr lang="en-US" sz="3200" b="1" dirty="0"/>
+              <a:t>Posting-based</a:t>
+            </a:r>
+            <a:r>
               <a:rPr lang="en-IL" sz="3200" b="1" dirty="0"/>
-              <a:t>Posting</a:t>
-            </a:r>
-            <a:r>
-              <a:rPr lang="en-US" sz="3200" b="1" dirty="0"/>
-              <a:t> </a:t>
-            </a:r>
-            <a:r>
-              <a:rPr lang="en-IL" sz="3200" b="1" dirty="0"/>
-              <a:t>based:</a:t>
+              <a:t>:</a:t>
             </a:r>
             <a:r>
               <a:rPr lang="en-IL" sz="3200" dirty="0"/>
-              <a:t> Posting dominance and top topic describe </a:t>
+              <a:t> Posting </a:t>
+            </a:r>
+            <a:r>
+              <a:rPr lang="en-US" sz="3200" dirty="0"/>
+              <a:t>activity and distribution across topics </a:t>
+            </a:r>
+            <a:r>
+              <a:rPr lang="en-IL" sz="3200" dirty="0"/>
+              <a:t>describe </a:t>
             </a:r>
             <a:r>
               <a:rPr lang="en-US" sz="3200" dirty="0"/>
@@ -11981,14 +11981,33 @@
         </p:spPr>
         <p:txBody>
           <a:bodyPr>
-            <a:normAutofit fontScale="92500"/>
+            <a:normAutofit fontScale="92500" lnSpcReduction="20000"/>
           </a:bodyPr>
           <a:lstStyle/>
           <a:p>
             <a:r>
-              <a:rPr lang="en-IL" dirty="0"/>
-              <a:t>TF-IDF is a statistical method used in natural language processing and information retrieval to evaluate how important a word is to a document in relation to a larger collection of documents.</a:t>
-            </a:r>
+              <a:rPr lang="en-IL" sz="2800" dirty="0"/>
+              <a:t>TF-IDF is a statistical method used in natural language processing and information retrieval to evaluate how important a word is to a document</a:t>
+            </a:r>
+            <a:r>
+              <a:rPr lang="en-US" sz="2800" dirty="0"/>
+              <a:t> (in our project – topic) </a:t>
+            </a:r>
+            <a:r>
+              <a:rPr lang="en-IL" sz="2800" dirty="0"/>
+              <a:t>in relation to a larger collection of documents</a:t>
+            </a:r>
+            <a:r>
+              <a:rPr lang="en-US" sz="2800" dirty="0"/>
+              <a:t> (topics)</a:t>
+            </a:r>
+            <a:r>
+              <a:rPr lang="en-IL" sz="2800" dirty="0"/>
+              <a:t>.</a:t>
+            </a:r>
+            <a:endParaRPr lang="en-US" sz="2800" dirty="0"/>
+          </a:p>
+          <a:p>
             <a:endParaRPr lang="en-US" dirty="0"/>
           </a:p>
           <a:p>
@@ -12007,43 +12026,57 @@
             <a:endParaRPr lang="en-US" dirty="0"/>
           </a:p>
           <a:p>
+            <a:pPr marL="0" indent="0">
+              <a:buNone/>
+            </a:pPr>
             <a:endParaRPr lang="en-US" dirty="0"/>
           </a:p>
           <a:p>
             <a:r>
-              <a:rPr lang="en-IL" spc="12" dirty="0">
-                <a:solidFill>
-                  <a:srgbClr val="273239"/>
-                </a:solidFill>
-                <a:latin typeface="Nunito" pitchFamily="2" charset="0"/>
-              </a:rPr>
-              <a:t>This allows TF-IDF to highlight terms that are both frequent within a specific document and distinctive across the text document, making it a useful tool for tasks like search ranking, text classification</a:t>
-            </a:r>
-            <a:r>
-              <a:rPr lang="en-US" spc="12" dirty="0">
-                <a:solidFill>
-                  <a:srgbClr val="273239"/>
-                </a:solidFill>
-                <a:latin typeface="Nunito" pitchFamily="2" charset="0"/>
-              </a:rPr>
+              <a:rPr lang="en-IL" sz="2800" dirty="0"/>
+              <a:t>This allows TF-IDF to highlight terms that are both frequent within a specific document </a:t>
+            </a:r>
+            <a:r>
+              <a:rPr lang="en-US" sz="2800" dirty="0"/>
+              <a:t>(topic) </a:t>
+            </a:r>
+            <a:r>
+              <a:rPr lang="en-IL" sz="2800" dirty="0"/>
+              <a:t>and distinctive across the </a:t>
+            </a:r>
+            <a:r>
+              <a:rPr lang="en-US" sz="2800" dirty="0"/>
+              <a:t>other</a:t>
+            </a:r>
+            <a:r>
+              <a:rPr lang="en-IL" sz="2800" dirty="0"/>
+              <a:t> document</a:t>
+            </a:r>
+            <a:r>
+              <a:rPr lang="en-US" sz="2800" dirty="0"/>
+              <a:t>s (topics)</a:t>
+            </a:r>
+            <a:r>
+              <a:rPr lang="en-IL" sz="2800" dirty="0"/>
+              <a:t>, making it a useful tool for tasks like search</a:t>
+            </a:r>
+            <a:r>
+              <a:rPr lang="en-US" sz="2800" dirty="0"/>
+              <a:t>, </a:t>
+            </a:r>
+            <a:r>
+              <a:rPr lang="en-IL" sz="2800" dirty="0"/>
+              <a:t>ranking, text classification</a:t>
+            </a:r>
+            <a:r>
+              <a:rPr lang="en-US" sz="2800" dirty="0"/>
               <a:t>,</a:t>
             </a:r>
             <a:r>
-              <a:rPr lang="en-IL" spc="12" dirty="0">
-                <a:solidFill>
-                  <a:srgbClr val="273239"/>
-                </a:solidFill>
-                <a:latin typeface="Nunito" pitchFamily="2" charset="0"/>
-              </a:rPr>
+              <a:rPr lang="en-IL" sz="2800" dirty="0"/>
               <a:t> and keyword extraction.</a:t>
             </a:r>
-            <a:endParaRPr lang="en-IL" dirty="0"/>
-          </a:p>
-          <a:p>
             <a:endParaRPr lang="en-US" dirty="0"/>
-          </a:p>
-          <a:p>
-            <a:endParaRPr lang="en-US" sz="3200" dirty="0"/>
           </a:p>
         </p:txBody>
       </p:sp>
@@ -12824,10 +12857,10 @@
       </p:grpSpPr>
       <p:pic>
         <p:nvPicPr>
-          <p:cNvPr id="6" name="Picture 5">
-            <a:extLst>
-              <a:ext uri="{FF2B5EF4-FFF2-40B4-BE49-F238E27FC236}">
-                <a16:creationId xmlns:a16="http://schemas.microsoft.com/office/drawing/2014/main" id="{AF6BC6AE-4687-A2A7-935B-0F2E9F9154B3}"/>
+          <p:cNvPr id="13" name="Picture 12">
+            <a:extLst>
+              <a:ext uri="{FF2B5EF4-FFF2-40B4-BE49-F238E27FC236}">
+                <a16:creationId xmlns:a16="http://schemas.microsoft.com/office/drawing/2014/main" id="{EACD9694-1A43-6A99-9FB5-92F2E3269813}"/>
               </a:ext>
             </a:extLst>
           </p:cNvPr>
@@ -12844,8 +12877,8 @@
         </p:blipFill>
         <p:spPr>
           <a:xfrm>
-            <a:off x="1094873" y="1846582"/>
-            <a:ext cx="5256000" cy="2467525"/>
+            <a:off x="6472704" y="1815145"/>
+            <a:ext cx="5256000" cy="2467272"/>
           </a:xfrm>
           <a:prstGeom prst="rect">
             <a:avLst/>
@@ -12854,10 +12887,10 @@
       </p:pic>
       <p:pic>
         <p:nvPicPr>
-          <p:cNvPr id="9" name="Picture 8">
-            <a:extLst>
-              <a:ext uri="{FF2B5EF4-FFF2-40B4-BE49-F238E27FC236}">
-                <a16:creationId xmlns:a16="http://schemas.microsoft.com/office/drawing/2014/main" id="{142AE667-C784-0DA7-5A0E-CB08BA36F635}"/>
+          <p:cNvPr id="11" name="Picture 10">
+            <a:extLst>
+              <a:ext uri="{FF2B5EF4-FFF2-40B4-BE49-F238E27FC236}">
+                <a16:creationId xmlns:a16="http://schemas.microsoft.com/office/drawing/2014/main" id="{F34E6B33-86DC-CDB5-7F76-2E51DD368689}"/>
               </a:ext>
             </a:extLst>
           </p:cNvPr>
@@ -12874,8 +12907,8 @@
         </p:blipFill>
         <p:spPr>
           <a:xfrm>
-            <a:off x="6473236" y="1825623"/>
-            <a:ext cx="5255468" cy="2467273"/>
+            <a:off x="1094873" y="1825369"/>
+            <a:ext cx="5256000" cy="2467273"/>
           </a:xfrm>
           <a:prstGeom prst="rect">
             <a:avLst/>
@@ -13217,6 +13250,37 @@
           </a:p>
         </p:txBody>
       </p:sp>
+      <p:pic>
+        <p:nvPicPr>
+          <p:cNvPr id="8" name="Picture 7">
+            <a:extLst>
+              <a:ext uri="{FF2B5EF4-FFF2-40B4-BE49-F238E27FC236}">
+                <a16:creationId xmlns:a16="http://schemas.microsoft.com/office/drawing/2014/main" id="{E3276C4B-DA0A-5111-1A73-FF50FBCD2517}"/>
+              </a:ext>
+            </a:extLst>
+          </p:cNvPr>
+          <p:cNvPicPr>
+            <a:picLocks noChangeAspect="1"/>
+          </p:cNvPicPr>
+          <p:nvPr/>
+        </p:nvPicPr>
+        <p:blipFill>
+          <a:blip r:embed="rId2"/>
+          <a:srcRect t="6179" b="4551"/>
+          <a:stretch>
+            <a:fillRect/>
+          </a:stretch>
+        </p:blipFill>
+        <p:spPr>
+          <a:xfrm>
+            <a:off x="6824310" y="1260908"/>
+            <a:ext cx="5361514" cy="4880009"/>
+          </a:xfrm>
+          <a:prstGeom prst="rect">
+            <a:avLst/>
+          </a:prstGeom>
+        </p:spPr>
+      </p:pic>
       <p:sp>
         <p:nvSpPr>
           <p:cNvPr id="3" name="Content Placeholder 2">
@@ -13257,26 +13321,42 @@
           <a:p>
             <a:pPr lvl="1"/>
             <a:r>
-              <a:rPr lang="en-IL" sz="1500" dirty="0"/>
+              <a:rPr lang="en-IL" sz="2000" dirty="0"/>
               <a:t>Account ID:</a:t>
             </a:r>
             <a:r>
-              <a:rPr lang="en-GB" sz="1500" dirty="0"/>
+              <a:rPr lang="en-GB" sz="2000" dirty="0"/>
               <a:t> </a:t>
             </a:r>
             <a:r>
-              <a:rPr lang="en-IL" sz="1500" dirty="0"/>
-              <a:t>71cc57155d061d447c2c65756c7dfd6873e403a097</a:t>
-            </a:r>
-            <a:endParaRPr lang="en-GB" sz="1500" dirty="0"/>
+              <a:rPr lang="en-IL" sz="2000" dirty="0"/>
+              <a:t>0020fd</a:t>
+            </a:r>
+            <a:r>
+              <a:rPr lang="en-US" sz="2000" dirty="0"/>
+              <a:t>…</a:t>
+            </a:r>
+            <a:r>
+              <a:rPr lang="en-IL" sz="2000" dirty="0"/>
+              <a:t>29eae6</a:t>
+            </a:r>
+            <a:endParaRPr lang="en-GB" sz="2000" dirty="0"/>
           </a:p>
           <a:p>
             <a:pPr lvl="1"/>
             <a:r>
-              <a:rPr lang="en-IL" sz="1500" dirty="0"/>
-              <a:t>Core number: 106 </a:t>
-            </a:r>
-            <a:endParaRPr lang="en-GB" sz="1500" dirty="0"/>
+              <a:rPr lang="en-IL" sz="2000" dirty="0"/>
+              <a:t>Core number: </a:t>
+            </a:r>
+            <a:r>
+              <a:rPr lang="en-IL" sz="2000" b="1" dirty="0"/>
+              <a:t>475</a:t>
+            </a:r>
+            <a:r>
+              <a:rPr lang="en-IL" sz="2000" dirty="0"/>
+              <a:t> </a:t>
+            </a:r>
+            <a:endParaRPr lang="en-GB" sz="2000" dirty="0"/>
           </a:p>
           <a:p>
             <a:r>
@@ -13355,37 +13435,6 @@
           </a:p>
         </p:txBody>
       </p:sp>
-      <p:pic>
-        <p:nvPicPr>
-          <p:cNvPr id="14" name="Content Placeholder 13">
-            <a:extLst>
-              <a:ext uri="{FF2B5EF4-FFF2-40B4-BE49-F238E27FC236}">
-                <a16:creationId xmlns:a16="http://schemas.microsoft.com/office/drawing/2014/main" id="{90FD3490-4134-E81B-C98D-221084472996}"/>
-              </a:ext>
-            </a:extLst>
-          </p:cNvPr>
-          <p:cNvPicPr>
-            <a:picLocks noChangeAspect="1"/>
-          </p:cNvPicPr>
-          <p:nvPr/>
-        </p:nvPicPr>
-        <p:blipFill>
-          <a:blip r:embed="rId2"/>
-          <a:srcRect l="7336" t="8037" r="8100" b="7627"/>
-          <a:stretch>
-            <a:fillRect/>
-          </a:stretch>
-        </p:blipFill>
-        <p:spPr>
-          <a:xfrm>
-            <a:off x="6841153" y="1727200"/>
-            <a:ext cx="5181600" cy="4360820"/>
-          </a:xfrm>
-          <a:prstGeom prst="rect">
-            <a:avLst/>
-          </a:prstGeom>
-        </p:spPr>
-      </p:pic>
     </p:spTree>
     <p:extLst>
       <p:ext uri="{BB962C8B-B14F-4D97-AF65-F5344CB8AC3E}">
@@ -13683,6 +13732,66 @@
           </a:p>
         </p:txBody>
       </p:sp>
+      <p:pic>
+        <p:nvPicPr>
+          <p:cNvPr id="5" name="Picture 4">
+            <a:extLst>
+              <a:ext uri="{FF2B5EF4-FFF2-40B4-BE49-F238E27FC236}">
+                <a16:creationId xmlns:a16="http://schemas.microsoft.com/office/drawing/2014/main" id="{E222A37C-A8E8-C89D-4F95-3C9E025C6B2A}"/>
+              </a:ext>
+            </a:extLst>
+          </p:cNvPr>
+          <p:cNvPicPr>
+            <a:picLocks noChangeAspect="1"/>
+          </p:cNvPicPr>
+          <p:nvPr/>
+        </p:nvPicPr>
+        <p:blipFill>
+          <a:blip r:embed="rId2"/>
+          <a:stretch>
+            <a:fillRect/>
+          </a:stretch>
+        </p:blipFill>
+        <p:spPr>
+          <a:xfrm>
+            <a:off x="1554480" y="1691640"/>
+            <a:ext cx="3721608" cy="2011680"/>
+          </a:xfrm>
+          <a:prstGeom prst="rect">
+            <a:avLst/>
+          </a:prstGeom>
+        </p:spPr>
+      </p:pic>
+      <p:pic>
+        <p:nvPicPr>
+          <p:cNvPr id="9" name="Picture 8">
+            <a:extLst>
+              <a:ext uri="{FF2B5EF4-FFF2-40B4-BE49-F238E27FC236}">
+                <a16:creationId xmlns:a16="http://schemas.microsoft.com/office/drawing/2014/main" id="{2E8BBE46-ADCC-4E3D-242E-8FD64A7EF21A}"/>
+              </a:ext>
+            </a:extLst>
+          </p:cNvPr>
+          <p:cNvPicPr>
+            <a:picLocks noChangeAspect="1"/>
+          </p:cNvPicPr>
+          <p:nvPr/>
+        </p:nvPicPr>
+        <p:blipFill>
+          <a:blip r:embed="rId3"/>
+          <a:stretch>
+            <a:fillRect/>
+          </a:stretch>
+        </p:blipFill>
+        <p:spPr>
+          <a:xfrm>
+            <a:off x="6720840" y="1726840"/>
+            <a:ext cx="3721608" cy="2012400"/>
+          </a:xfrm>
+          <a:prstGeom prst="rect">
+            <a:avLst/>
+          </a:prstGeom>
+        </p:spPr>
+      </p:pic>
       <p:sp>
         <p:nvSpPr>
           <p:cNvPr id="4" name="Slide Number Placeholder 3">
@@ -13729,36 +13838,6 @@
           </a:p>
         </p:txBody>
       </p:sp>
-      <p:pic>
-        <p:nvPicPr>
-          <p:cNvPr id="6" name="Picture 5">
-            <a:extLst>
-              <a:ext uri="{FF2B5EF4-FFF2-40B4-BE49-F238E27FC236}">
-                <a16:creationId xmlns:a16="http://schemas.microsoft.com/office/drawing/2014/main" id="{696B63D4-DBEB-D4C9-9C41-EA06F53EBB94}"/>
-              </a:ext>
-            </a:extLst>
-          </p:cNvPr>
-          <p:cNvPicPr>
-            <a:picLocks noChangeAspect="1"/>
-          </p:cNvPicPr>
-          <p:nvPr/>
-        </p:nvPicPr>
-        <p:blipFill>
-          <a:blip r:embed="rId2"/>
-          <a:stretch>
-            <a:fillRect/>
-          </a:stretch>
-        </p:blipFill>
-        <p:spPr>
-          <a:xfrm>
-            <a:off x="1554480" y="1755648"/>
-            <a:ext cx="3721608" cy="2011680"/>
-          </a:xfrm>
-          <a:prstGeom prst="rect">
-            <a:avLst/>
-          </a:prstGeom>
-        </p:spPr>
-      </p:pic>
       <p:sp>
         <p:nvSpPr>
           <p:cNvPr id="8" name="TextBox 7">
@@ -13774,7 +13853,7 @@
         <p:spPr>
           <a:xfrm>
             <a:off x="1554480" y="3803904"/>
-            <a:ext cx="4566674" cy="307777"/>
+            <a:ext cx="3721608" cy="307777"/>
           </a:xfrm>
           <a:prstGeom prst="rect">
             <a:avLst/>
@@ -13794,41 +13873,20 @@
             </a:r>
             <a:r>
               <a:rPr lang="en-IL" sz="1400" dirty="0"/>
-              <a:t>71cc5715…e403a097</a:t>
-            </a:r>
+              <a:t>0020fd</a:t>
+            </a:r>
+            <a:r>
+              <a:rPr lang="en-US" sz="1400" dirty="0"/>
+              <a:t>…</a:t>
+            </a:r>
+            <a:r>
+              <a:rPr lang="en-IL" sz="1400" dirty="0"/>
+              <a:t>29eae6</a:t>
+            </a:r>
+            <a:endParaRPr lang="en-GB" sz="1400" dirty="0"/>
           </a:p>
         </p:txBody>
       </p:sp>
-      <p:pic>
-        <p:nvPicPr>
-          <p:cNvPr id="12" name="Picture 11">
-            <a:extLst>
-              <a:ext uri="{FF2B5EF4-FFF2-40B4-BE49-F238E27FC236}">
-                <a16:creationId xmlns:a16="http://schemas.microsoft.com/office/drawing/2014/main" id="{ABCB8A62-3788-74C2-C02D-A15EE6DA348A}"/>
-              </a:ext>
-            </a:extLst>
-          </p:cNvPr>
-          <p:cNvPicPr>
-            <a:picLocks noChangeAspect="1"/>
-          </p:cNvPicPr>
-          <p:nvPr/>
-        </p:nvPicPr>
-        <p:blipFill>
-          <a:blip r:embed="rId3"/>
-          <a:stretch>
-            <a:fillRect/>
-          </a:stretch>
-        </p:blipFill>
-        <p:spPr>
-          <a:xfrm>
-            <a:off x="6720840" y="1755648"/>
-            <a:ext cx="3721608" cy="2011680"/>
-          </a:xfrm>
-          <a:prstGeom prst="rect">
-            <a:avLst/>
-          </a:prstGeom>
-        </p:spPr>
-      </p:pic>
       <p:sp>
         <p:nvSpPr>
           <p:cNvPr id="16" name="TextBox 15">
@@ -13843,8 +13901,8 @@
         </p:nvSpPr>
         <p:spPr>
           <a:xfrm>
-            <a:off x="6720840" y="3803904"/>
-            <a:ext cx="4664931" cy="307777"/>
+            <a:off x="6720841" y="3803904"/>
+            <a:ext cx="3721608" cy="307777"/>
           </a:xfrm>
           <a:prstGeom prst="rect">
             <a:avLst/>
@@ -13864,7 +13922,15 @@
             </a:r>
             <a:r>
               <a:rPr lang="en-IL" sz="1400" dirty="0"/>
-              <a:t>712125a6…a3f9d0f</a:t>
+              <a:t>50820</a:t>
+            </a:r>
+            <a:r>
+              <a:rPr lang="en-US" sz="1400" dirty="0"/>
+              <a:t>e…</a:t>
+            </a:r>
+            <a:r>
+              <a:rPr lang="en-IL" sz="1400" dirty="0"/>
+              <a:t>bf60a3</a:t>
             </a:r>
           </a:p>
         </p:txBody>
@@ -13896,88 +13962,2323 @@
           </a:p>
         </p:txBody>
       </p:sp>
+      <p:graphicFrame>
+        <p:nvGraphicFramePr>
+          <p:cNvPr id="10" name="Table 9">
+            <a:extLst>
+              <a:ext uri="{FF2B5EF4-FFF2-40B4-BE49-F238E27FC236}">
+                <a16:creationId xmlns:a16="http://schemas.microsoft.com/office/drawing/2014/main" id="{956F4358-318F-7434-FEAC-78E8161990A9}"/>
+              </a:ext>
+            </a:extLst>
+          </p:cNvPr>
+          <p:cNvGraphicFramePr>
+            <a:graphicFrameLocks noGrp="1"/>
+          </p:cNvGraphicFramePr>
+          <p:nvPr>
+            <p:extLst>
+              <p:ext uri="{D42A27DB-BD31-4B8C-83A1-F6EECF244321}">
+                <p14:modId xmlns:p14="http://schemas.microsoft.com/office/powerpoint/2010/main" val="2949915631"/>
+              </p:ext>
+            </p:extLst>
+          </p:nvPr>
+        </p:nvGraphicFramePr>
+        <p:xfrm>
+          <a:off x="751399" y="4197717"/>
+          <a:ext cx="5232287" cy="2140530"/>
+        </p:xfrm>
+        <a:graphic>
+          <a:graphicData uri="http://schemas.openxmlformats.org/drawingml/2006/table">
+            <a:tbl>
+              <a:tblPr/>
+              <a:tblGrid>
+                <a:gridCol w="1744096">
+                  <a:extLst>
+                    <a:ext uri="{9D8B030D-6E8A-4147-A177-3AD203B41FA5}">
+                      <a16:colId xmlns:a16="http://schemas.microsoft.com/office/drawing/2014/main" val="2874528193"/>
+                    </a:ext>
+                  </a:extLst>
+                </a:gridCol>
+                <a:gridCol w="901856">
+                  <a:extLst>
+                    <a:ext uri="{9D8B030D-6E8A-4147-A177-3AD203B41FA5}">
+                      <a16:colId xmlns:a16="http://schemas.microsoft.com/office/drawing/2014/main" val="3340295290"/>
+                    </a:ext>
+                  </a:extLst>
+                </a:gridCol>
+                <a:gridCol w="2586335">
+                  <a:extLst>
+                    <a:ext uri="{9D8B030D-6E8A-4147-A177-3AD203B41FA5}">
+                      <a16:colId xmlns:a16="http://schemas.microsoft.com/office/drawing/2014/main" val="1026010249"/>
+                    </a:ext>
+                  </a:extLst>
+                </a:gridCol>
+              </a:tblGrid>
+              <a:tr h="287386">
+                <a:tc>
+                  <a:txBody>
+                    <a:bodyPr/>
+                    <a:lstStyle/>
+                    <a:p>
+                      <a:pPr algn="l" fontAlgn="ctr">
+                        <a:buNone/>
+                      </a:pPr>
+                      <a:r>
+                        <a:rPr lang="en-IL" sz="1050" b="0" i="0" dirty="0" err="1">
+                          <a:solidFill>
+                            <a:schemeClr val="bg1"/>
+                          </a:solidFill>
+                          <a:effectLst/>
+                          <a:latin typeface="Segoe WPC"/>
+                        </a:rPr>
+                        <a:t>post_time</a:t>
+                      </a:r>
+                      <a:endParaRPr lang="en-IL" sz="1050" b="0" i="0" dirty="0">
+                        <a:solidFill>
+                          <a:schemeClr val="bg1"/>
+                        </a:solidFill>
+                        <a:effectLst/>
+                        <a:latin typeface="Segoe WPC"/>
+                      </a:endParaRPr>
+                    </a:p>
+                  </a:txBody>
+                  <a:tcPr marL="60960" marR="60960" marT="30480" marB="30480" anchor="ctr">
+                    <a:lnL w="12700" cap="flat" cmpd="sng" algn="ctr">
+                      <a:noFill/>
+                      <a:prstDash val="solid"/>
+                      <a:round/>
+                      <a:headEnd type="none" w="med" len="med"/>
+                      <a:tailEnd type="none" w="med" len="med"/>
+                    </a:lnL>
+                    <a:lnR w="12700" cap="flat" cmpd="sng" algn="ctr">
+                      <a:noFill/>
+                      <a:prstDash val="solid"/>
+                      <a:round/>
+                      <a:headEnd type="none" w="med" len="med"/>
+                      <a:tailEnd type="none" w="med" len="med"/>
+                    </a:lnR>
+                    <a:lnT w="12700" cap="flat" cmpd="sng" algn="ctr">
+                      <a:noFill/>
+                      <a:prstDash val="solid"/>
+                      <a:round/>
+                      <a:headEnd type="none" w="med" len="med"/>
+                      <a:tailEnd type="none" w="med" len="med"/>
+                    </a:lnT>
+                    <a:lnB w="12700" cap="flat" cmpd="sng" algn="ctr">
+                      <a:noFill/>
+                      <a:prstDash val="solid"/>
+                      <a:round/>
+                      <a:headEnd type="none" w="med" len="med"/>
+                      <a:tailEnd type="none" w="med" len="med"/>
+                    </a:lnB>
+                    <a:solidFill>
+                      <a:schemeClr val="tx1"/>
+                    </a:solidFill>
+                  </a:tcPr>
+                </a:tc>
+                <a:tc>
+                  <a:txBody>
+                    <a:bodyPr/>
+                    <a:lstStyle/>
+                    <a:p>
+                      <a:pPr algn="l" fontAlgn="ctr">
+                        <a:buNone/>
+                      </a:pPr>
+                      <a:r>
+                        <a:rPr lang="en-IL" sz="1050" b="0" i="0">
+                          <a:solidFill>
+                            <a:schemeClr val="bg1"/>
+                          </a:solidFill>
+                          <a:effectLst/>
+                          <a:latin typeface="Segoe WPC"/>
+                        </a:rPr>
+                        <a:t>post_tfidf</a:t>
+                      </a:r>
+                    </a:p>
+                  </a:txBody>
+                  <a:tcPr marL="60960" marR="60960" marT="30480" marB="30480" anchor="ctr">
+                    <a:lnL w="12700" cap="flat" cmpd="sng" algn="ctr">
+                      <a:noFill/>
+                      <a:prstDash val="solid"/>
+                      <a:round/>
+                      <a:headEnd type="none" w="med" len="med"/>
+                      <a:tailEnd type="none" w="med" len="med"/>
+                    </a:lnL>
+                    <a:lnR w="12700" cap="flat" cmpd="sng" algn="ctr">
+                      <a:noFill/>
+                      <a:prstDash val="solid"/>
+                      <a:round/>
+                      <a:headEnd type="none" w="med" len="med"/>
+                      <a:tailEnd type="none" w="med" len="med"/>
+                    </a:lnR>
+                    <a:lnT w="12700" cap="flat" cmpd="sng" algn="ctr">
+                      <a:noFill/>
+                      <a:prstDash val="solid"/>
+                      <a:round/>
+                      <a:headEnd type="none" w="med" len="med"/>
+                      <a:tailEnd type="none" w="med" len="med"/>
+                    </a:lnT>
+                    <a:lnB w="12700" cap="flat" cmpd="sng" algn="ctr">
+                      <a:noFill/>
+                      <a:prstDash val="solid"/>
+                      <a:round/>
+                      <a:headEnd type="none" w="med" len="med"/>
+                      <a:tailEnd type="none" w="med" len="med"/>
+                    </a:lnB>
+                    <a:solidFill>
+                      <a:schemeClr val="tx1"/>
+                    </a:solidFill>
+                  </a:tcPr>
+                </a:tc>
+                <a:tc>
+                  <a:txBody>
+                    <a:bodyPr/>
+                    <a:lstStyle/>
+                    <a:p>
+                      <a:pPr algn="l" fontAlgn="ctr">
+                        <a:buNone/>
+                      </a:pPr>
+                      <a:r>
+                        <a:rPr lang="en-IL" sz="1050" b="0" i="0" dirty="0" err="1">
+                          <a:solidFill>
+                            <a:schemeClr val="bg1"/>
+                          </a:solidFill>
+                          <a:effectLst/>
+                          <a:latin typeface="Segoe WPC"/>
+                        </a:rPr>
+                        <a:t>translated_post</a:t>
+                      </a:r>
+                      <a:endParaRPr lang="en-IL" sz="1050" b="0" i="0" dirty="0">
+                        <a:solidFill>
+                          <a:schemeClr val="bg1"/>
+                        </a:solidFill>
+                        <a:effectLst/>
+                        <a:latin typeface="Segoe WPC"/>
+                      </a:endParaRPr>
+                    </a:p>
+                  </a:txBody>
+                  <a:tcPr marL="60960" marR="60960" marT="30480" marB="30480" anchor="ctr">
+                    <a:lnL w="12700" cap="flat" cmpd="sng" algn="ctr">
+                      <a:noFill/>
+                      <a:prstDash val="solid"/>
+                      <a:round/>
+                      <a:headEnd type="none" w="med" len="med"/>
+                      <a:tailEnd type="none" w="med" len="med"/>
+                    </a:lnL>
+                    <a:lnR w="12700" cap="flat" cmpd="sng" algn="ctr">
+                      <a:noFill/>
+                      <a:prstDash val="solid"/>
+                      <a:round/>
+                      <a:headEnd type="none" w="med" len="med"/>
+                      <a:tailEnd type="none" w="med" len="med"/>
+                    </a:lnR>
+                    <a:lnT w="12700" cap="flat" cmpd="sng" algn="ctr">
+                      <a:noFill/>
+                      <a:prstDash val="solid"/>
+                      <a:round/>
+                      <a:headEnd type="none" w="med" len="med"/>
+                      <a:tailEnd type="none" w="med" len="med"/>
+                    </a:lnT>
+                    <a:lnB w="12700" cap="flat" cmpd="sng" algn="ctr">
+                      <a:noFill/>
+                      <a:prstDash val="solid"/>
+                      <a:round/>
+                      <a:headEnd type="none" w="med" len="med"/>
+                      <a:tailEnd type="none" w="med" len="med"/>
+                    </a:lnB>
+                    <a:solidFill>
+                      <a:schemeClr val="tx1"/>
+                    </a:solidFill>
+                  </a:tcPr>
+                </a:tc>
+                <a:extLst>
+                  <a:ext uri="{0D108BD9-81ED-4DB2-BD59-A6C34878D82A}">
+                    <a16:rowId xmlns:a16="http://schemas.microsoft.com/office/drawing/2014/main" val="2259309303"/>
+                  </a:ext>
+                </a:extLst>
+              </a:tr>
+              <a:tr h="287386">
+                <a:tc>
+                  <a:txBody>
+                    <a:bodyPr/>
+                    <a:lstStyle/>
+                    <a:p>
+                      <a:pPr algn="l" fontAlgn="ctr">
+                        <a:buNone/>
+                      </a:pPr>
+                      <a:r>
+                        <a:rPr lang="en-IL" sz="1050" b="0" i="0">
+                          <a:solidFill>
+                            <a:schemeClr val="bg1"/>
+                          </a:solidFill>
+                          <a:effectLst/>
+                          <a:latin typeface="Segoe WPC"/>
+                        </a:rPr>
+                        <a:t>2018-04-11 21:20:00</a:t>
+                      </a:r>
+                    </a:p>
+                  </a:txBody>
+                  <a:tcPr marL="60960" marR="60960" marT="30480" marB="30480" anchor="ctr">
+                    <a:lnL w="12700" cap="flat" cmpd="sng" algn="ctr">
+                      <a:noFill/>
+                      <a:prstDash val="solid"/>
+                      <a:round/>
+                      <a:headEnd type="none" w="med" len="med"/>
+                      <a:tailEnd type="none" w="med" len="med"/>
+                    </a:lnL>
+                    <a:lnR w="12700" cap="flat" cmpd="sng" algn="ctr">
+                      <a:noFill/>
+                      <a:prstDash val="solid"/>
+                      <a:round/>
+                      <a:headEnd type="none" w="med" len="med"/>
+                      <a:tailEnd type="none" w="med" len="med"/>
+                    </a:lnR>
+                    <a:lnT w="12700" cap="flat" cmpd="sng" algn="ctr">
+                      <a:noFill/>
+                      <a:prstDash val="solid"/>
+                      <a:round/>
+                      <a:headEnd type="none" w="med" len="med"/>
+                      <a:tailEnd type="none" w="med" len="med"/>
+                    </a:lnT>
+                    <a:lnB w="12700" cap="flat" cmpd="sng" algn="ctr">
+                      <a:noFill/>
+                      <a:prstDash val="solid"/>
+                      <a:round/>
+                      <a:headEnd type="none" w="med" len="med"/>
+                      <a:tailEnd type="none" w="med" len="med"/>
+                    </a:lnB>
+                    <a:solidFill>
+                      <a:schemeClr val="tx1"/>
+                    </a:solidFill>
+                  </a:tcPr>
+                </a:tc>
+                <a:tc>
+                  <a:txBody>
+                    <a:bodyPr/>
+                    <a:lstStyle/>
+                    <a:p>
+                      <a:pPr algn="l" fontAlgn="ctr">
+                        <a:buNone/>
+                      </a:pPr>
+                      <a:r>
+                        <a:rPr lang="en-IL" sz="1050" b="0" i="0" dirty="0">
+                          <a:solidFill>
+                            <a:schemeClr val="bg1"/>
+                          </a:solidFill>
+                          <a:effectLst/>
+                          <a:latin typeface="Segoe WPC"/>
+                        </a:rPr>
+                        <a:t>1.953884</a:t>
+                      </a:r>
+                    </a:p>
+                  </a:txBody>
+                  <a:tcPr marL="60960" marR="60960" marT="30480" marB="30480" anchor="ctr">
+                    <a:lnL w="12700" cap="flat" cmpd="sng" algn="ctr">
+                      <a:noFill/>
+                      <a:prstDash val="solid"/>
+                      <a:round/>
+                      <a:headEnd type="none" w="med" len="med"/>
+                      <a:tailEnd type="none" w="med" len="med"/>
+                    </a:lnL>
+                    <a:lnR w="12700" cap="flat" cmpd="sng" algn="ctr">
+                      <a:noFill/>
+                      <a:prstDash val="solid"/>
+                      <a:round/>
+                      <a:headEnd type="none" w="med" len="med"/>
+                      <a:tailEnd type="none" w="med" len="med"/>
+                    </a:lnR>
+                    <a:lnT w="12700" cap="flat" cmpd="sng" algn="ctr">
+                      <a:noFill/>
+                      <a:prstDash val="solid"/>
+                      <a:round/>
+                      <a:headEnd type="none" w="med" len="med"/>
+                      <a:tailEnd type="none" w="med" len="med"/>
+                    </a:lnT>
+                    <a:lnB w="12700" cap="flat" cmpd="sng" algn="ctr">
+                      <a:noFill/>
+                      <a:prstDash val="solid"/>
+                      <a:round/>
+                      <a:headEnd type="none" w="med" len="med"/>
+                      <a:tailEnd type="none" w="med" len="med"/>
+                    </a:lnB>
+                    <a:solidFill>
+                      <a:schemeClr val="tx1"/>
+                    </a:solidFill>
+                  </a:tcPr>
+                </a:tc>
+                <a:tc>
+                  <a:txBody>
+                    <a:bodyPr/>
+                    <a:lstStyle/>
+                    <a:p>
+                      <a:pPr algn="l" fontAlgn="ctr">
+                        <a:buNone/>
+                      </a:pPr>
+                      <a:r>
+                        <a:rPr lang="en-IL" sz="1050" b="0" i="0" dirty="0">
+                          <a:solidFill>
+                            <a:schemeClr val="bg1"/>
+                          </a:solidFill>
+                          <a:effectLst/>
+                          <a:latin typeface="Segoe WPC"/>
+                        </a:rPr>
+                        <a:t>wheels mayor </a:t>
+                      </a:r>
+                    </a:p>
+                  </a:txBody>
+                  <a:tcPr marL="60960" marR="60960" marT="30480" marB="30480" anchor="ctr">
+                    <a:lnL w="12700" cap="flat" cmpd="sng" algn="ctr">
+                      <a:noFill/>
+                      <a:prstDash val="solid"/>
+                      <a:round/>
+                      <a:headEnd type="none" w="med" len="med"/>
+                      <a:tailEnd type="none" w="med" len="med"/>
+                    </a:lnL>
+                    <a:lnR w="12700" cap="flat" cmpd="sng" algn="ctr">
+                      <a:noFill/>
+                      <a:prstDash val="solid"/>
+                      <a:round/>
+                      <a:headEnd type="none" w="med" len="med"/>
+                      <a:tailEnd type="none" w="med" len="med"/>
+                    </a:lnR>
+                    <a:lnT w="12700" cap="flat" cmpd="sng" algn="ctr">
+                      <a:noFill/>
+                      <a:prstDash val="solid"/>
+                      <a:round/>
+                      <a:headEnd type="none" w="med" len="med"/>
+                      <a:tailEnd type="none" w="med" len="med"/>
+                    </a:lnT>
+                    <a:lnB w="12700" cap="flat" cmpd="sng" algn="ctr">
+                      <a:noFill/>
+                      <a:prstDash val="solid"/>
+                      <a:round/>
+                      <a:headEnd type="none" w="med" len="med"/>
+                      <a:tailEnd type="none" w="med" len="med"/>
+                    </a:lnB>
+                    <a:solidFill>
+                      <a:schemeClr val="tx1"/>
+                    </a:solidFill>
+                  </a:tcPr>
+                </a:tc>
+                <a:extLst>
+                  <a:ext uri="{0D108BD9-81ED-4DB2-BD59-A6C34878D82A}">
+                    <a16:rowId xmlns:a16="http://schemas.microsoft.com/office/drawing/2014/main" val="3401871322"/>
+                  </a:ext>
+                </a:extLst>
+              </a:tr>
+              <a:tr h="287386">
+                <a:tc>
+                  <a:txBody>
+                    <a:bodyPr/>
+                    <a:lstStyle/>
+                    <a:p>
+                      <a:pPr algn="l" fontAlgn="ctr">
+                        <a:buNone/>
+                      </a:pPr>
+                      <a:r>
+                        <a:rPr lang="en-IL" sz="1050" b="0" i="0" dirty="0">
+                          <a:solidFill>
+                            <a:schemeClr val="bg1"/>
+                          </a:solidFill>
+                          <a:effectLst/>
+                          <a:latin typeface="Segoe WPC"/>
+                        </a:rPr>
+                        <a:t>2018-04-11 21:44:00</a:t>
+                      </a:r>
+                    </a:p>
+                  </a:txBody>
+                  <a:tcPr marL="60960" marR="60960" marT="30480" marB="30480" anchor="ctr">
+                    <a:lnL w="12700" cap="flat" cmpd="sng" algn="ctr">
+                      <a:noFill/>
+                      <a:prstDash val="solid"/>
+                      <a:round/>
+                      <a:headEnd type="none" w="med" len="med"/>
+                      <a:tailEnd type="none" w="med" len="med"/>
+                    </a:lnL>
+                    <a:lnR w="12700" cap="flat" cmpd="sng" algn="ctr">
+                      <a:noFill/>
+                      <a:prstDash val="solid"/>
+                      <a:round/>
+                      <a:headEnd type="none" w="med" len="med"/>
+                      <a:tailEnd type="none" w="med" len="med"/>
+                    </a:lnR>
+                    <a:lnT w="12700" cap="flat" cmpd="sng" algn="ctr">
+                      <a:noFill/>
+                      <a:prstDash val="solid"/>
+                      <a:round/>
+                      <a:headEnd type="none" w="med" len="med"/>
+                      <a:tailEnd type="none" w="med" len="med"/>
+                    </a:lnT>
+                    <a:lnB w="12700" cap="flat" cmpd="sng" algn="ctr">
+                      <a:noFill/>
+                      <a:prstDash val="solid"/>
+                      <a:round/>
+                      <a:headEnd type="none" w="med" len="med"/>
+                      <a:tailEnd type="none" w="med" len="med"/>
+                    </a:lnB>
+                    <a:solidFill>
+                      <a:schemeClr val="tx1"/>
+                    </a:solidFill>
+                  </a:tcPr>
+                </a:tc>
+                <a:tc>
+                  <a:txBody>
+                    <a:bodyPr/>
+                    <a:lstStyle/>
+                    <a:p>
+                      <a:pPr algn="l" fontAlgn="ctr">
+                        <a:buNone/>
+                      </a:pPr>
+                      <a:r>
+                        <a:rPr lang="en-IL" sz="1050" b="0" i="0" dirty="0">
+                          <a:solidFill>
+                            <a:schemeClr val="bg1"/>
+                          </a:solidFill>
+                          <a:effectLst/>
+                          <a:latin typeface="Segoe WPC"/>
+                        </a:rPr>
+                        <a:t>1.953884</a:t>
+                      </a:r>
+                    </a:p>
+                  </a:txBody>
+                  <a:tcPr marL="60960" marR="60960" marT="30480" marB="30480" anchor="ctr">
+                    <a:lnL w="12700" cap="flat" cmpd="sng" algn="ctr">
+                      <a:noFill/>
+                      <a:prstDash val="solid"/>
+                      <a:round/>
+                      <a:headEnd type="none" w="med" len="med"/>
+                      <a:tailEnd type="none" w="med" len="med"/>
+                    </a:lnL>
+                    <a:lnR w="12700" cap="flat" cmpd="sng" algn="ctr">
+                      <a:noFill/>
+                      <a:prstDash val="solid"/>
+                      <a:round/>
+                      <a:headEnd type="none" w="med" len="med"/>
+                      <a:tailEnd type="none" w="med" len="med"/>
+                    </a:lnR>
+                    <a:lnT w="12700" cap="flat" cmpd="sng" algn="ctr">
+                      <a:noFill/>
+                      <a:prstDash val="solid"/>
+                      <a:round/>
+                      <a:headEnd type="none" w="med" len="med"/>
+                      <a:tailEnd type="none" w="med" len="med"/>
+                    </a:lnT>
+                    <a:lnB w="12700" cap="flat" cmpd="sng" algn="ctr">
+                      <a:noFill/>
+                      <a:prstDash val="solid"/>
+                      <a:round/>
+                      <a:headEnd type="none" w="med" len="med"/>
+                      <a:tailEnd type="none" w="med" len="med"/>
+                    </a:lnB>
+                    <a:solidFill>
+                      <a:schemeClr val="tx1"/>
+                    </a:solidFill>
+                  </a:tcPr>
+                </a:tc>
+                <a:tc>
+                  <a:txBody>
+                    <a:bodyPr/>
+                    <a:lstStyle/>
+                    <a:p>
+                      <a:pPr algn="l" fontAlgn="ctr">
+                        <a:buNone/>
+                      </a:pPr>
+                      <a:r>
+                        <a:rPr lang="en-IL" sz="1050" b="0" i="0" dirty="0">
+                          <a:solidFill>
+                            <a:schemeClr val="bg1"/>
+                          </a:solidFill>
+                          <a:effectLst/>
+                          <a:latin typeface="Segoe WPC"/>
+                        </a:rPr>
+                        <a:t>wheels mayor </a:t>
+                      </a:r>
+                    </a:p>
+                  </a:txBody>
+                  <a:tcPr marL="60960" marR="60960" marT="30480" marB="30480" anchor="ctr">
+                    <a:lnL w="12700" cap="flat" cmpd="sng" algn="ctr">
+                      <a:noFill/>
+                      <a:prstDash val="solid"/>
+                      <a:round/>
+                      <a:headEnd type="none" w="med" len="med"/>
+                      <a:tailEnd type="none" w="med" len="med"/>
+                    </a:lnL>
+                    <a:lnR w="12700" cap="flat" cmpd="sng" algn="ctr">
+                      <a:noFill/>
+                      <a:prstDash val="solid"/>
+                      <a:round/>
+                      <a:headEnd type="none" w="med" len="med"/>
+                      <a:tailEnd type="none" w="med" len="med"/>
+                    </a:lnR>
+                    <a:lnT w="12700" cap="flat" cmpd="sng" algn="ctr">
+                      <a:noFill/>
+                      <a:prstDash val="solid"/>
+                      <a:round/>
+                      <a:headEnd type="none" w="med" len="med"/>
+                      <a:tailEnd type="none" w="med" len="med"/>
+                    </a:lnT>
+                    <a:lnB w="12700" cap="flat" cmpd="sng" algn="ctr">
+                      <a:noFill/>
+                      <a:prstDash val="solid"/>
+                      <a:round/>
+                      <a:headEnd type="none" w="med" len="med"/>
+                      <a:tailEnd type="none" w="med" len="med"/>
+                    </a:lnB>
+                    <a:solidFill>
+                      <a:schemeClr val="tx1"/>
+                    </a:solidFill>
+                  </a:tcPr>
+                </a:tc>
+                <a:extLst>
+                  <a:ext uri="{0D108BD9-81ED-4DB2-BD59-A6C34878D82A}">
+                    <a16:rowId xmlns:a16="http://schemas.microsoft.com/office/drawing/2014/main" val="338417621"/>
+                  </a:ext>
+                </a:extLst>
+              </a:tr>
+              <a:tr h="287386">
+                <a:tc>
+                  <a:txBody>
+                    <a:bodyPr/>
+                    <a:lstStyle/>
+                    <a:p>
+                      <a:pPr algn="l" fontAlgn="ctr">
+                        <a:buNone/>
+                      </a:pPr>
+                      <a:r>
+                        <a:rPr lang="en-IL" sz="1050" b="0" i="0">
+                          <a:solidFill>
+                            <a:schemeClr val="bg1"/>
+                          </a:solidFill>
+                          <a:effectLst/>
+                          <a:latin typeface="Segoe WPC"/>
+                        </a:rPr>
+                        <a:t>2018-04-11 22:09:00</a:t>
+                      </a:r>
+                    </a:p>
+                  </a:txBody>
+                  <a:tcPr marL="60960" marR="60960" marT="30480" marB="30480" anchor="ctr">
+                    <a:lnL w="12700" cap="flat" cmpd="sng" algn="ctr">
+                      <a:noFill/>
+                      <a:prstDash val="solid"/>
+                      <a:round/>
+                      <a:headEnd type="none" w="med" len="med"/>
+                      <a:tailEnd type="none" w="med" len="med"/>
+                    </a:lnL>
+                    <a:lnR w="12700" cap="flat" cmpd="sng" algn="ctr">
+                      <a:noFill/>
+                      <a:prstDash val="solid"/>
+                      <a:round/>
+                      <a:headEnd type="none" w="med" len="med"/>
+                      <a:tailEnd type="none" w="med" len="med"/>
+                    </a:lnR>
+                    <a:lnT w="12700" cap="flat" cmpd="sng" algn="ctr">
+                      <a:noFill/>
+                      <a:prstDash val="solid"/>
+                      <a:round/>
+                      <a:headEnd type="none" w="med" len="med"/>
+                      <a:tailEnd type="none" w="med" len="med"/>
+                    </a:lnT>
+                    <a:lnB w="12700" cap="flat" cmpd="sng" algn="ctr">
+                      <a:noFill/>
+                      <a:prstDash val="solid"/>
+                      <a:round/>
+                      <a:headEnd type="none" w="med" len="med"/>
+                      <a:tailEnd type="none" w="med" len="med"/>
+                    </a:lnB>
+                    <a:solidFill>
+                      <a:schemeClr val="tx1"/>
+                    </a:solidFill>
+                  </a:tcPr>
+                </a:tc>
+                <a:tc>
+                  <a:txBody>
+                    <a:bodyPr/>
+                    <a:lstStyle/>
+                    <a:p>
+                      <a:pPr algn="l" fontAlgn="ctr">
+                        <a:buNone/>
+                      </a:pPr>
+                      <a:r>
+                        <a:rPr lang="en-IL" sz="1050" b="0" i="0" dirty="0">
+                          <a:solidFill>
+                            <a:schemeClr val="bg1"/>
+                          </a:solidFill>
+                          <a:effectLst/>
+                          <a:latin typeface="Segoe WPC"/>
+                        </a:rPr>
+                        <a:t>1.498701</a:t>
+                      </a:r>
+                    </a:p>
+                  </a:txBody>
+                  <a:tcPr marL="60960" marR="60960" marT="30480" marB="30480" anchor="ctr">
+                    <a:lnL w="12700" cap="flat" cmpd="sng" algn="ctr">
+                      <a:noFill/>
+                      <a:prstDash val="solid"/>
+                      <a:round/>
+                      <a:headEnd type="none" w="med" len="med"/>
+                      <a:tailEnd type="none" w="med" len="med"/>
+                    </a:lnL>
+                    <a:lnR w="12700" cap="flat" cmpd="sng" algn="ctr">
+                      <a:noFill/>
+                      <a:prstDash val="solid"/>
+                      <a:round/>
+                      <a:headEnd type="none" w="med" len="med"/>
+                      <a:tailEnd type="none" w="med" len="med"/>
+                    </a:lnR>
+                    <a:lnT w="12700" cap="flat" cmpd="sng" algn="ctr">
+                      <a:noFill/>
+                      <a:prstDash val="solid"/>
+                      <a:round/>
+                      <a:headEnd type="none" w="med" len="med"/>
+                      <a:tailEnd type="none" w="med" len="med"/>
+                    </a:lnT>
+                    <a:lnB w="12700" cap="flat" cmpd="sng" algn="ctr">
+                      <a:noFill/>
+                      <a:prstDash val="solid"/>
+                      <a:round/>
+                      <a:headEnd type="none" w="med" len="med"/>
+                      <a:tailEnd type="none" w="med" len="med"/>
+                    </a:lnB>
+                    <a:solidFill>
+                      <a:schemeClr val="tx1"/>
+                    </a:solidFill>
+                  </a:tcPr>
+                </a:tc>
+                <a:tc>
+                  <a:txBody>
+                    <a:bodyPr/>
+                    <a:lstStyle/>
+                    <a:p>
+                      <a:pPr algn="l" fontAlgn="ctr">
+                        <a:buNone/>
+                      </a:pPr>
+                      <a:r>
+                        <a:rPr lang="en-IL" sz="1050" b="0" i="0" dirty="0">
+                          <a:solidFill>
+                            <a:schemeClr val="bg1"/>
+                          </a:solidFill>
+                          <a:effectLst/>
+                          <a:latin typeface="Segoe WPC"/>
+                        </a:rPr>
+                        <a:t>wheels mayor </a:t>
+                      </a:r>
+                    </a:p>
+                  </a:txBody>
+                  <a:tcPr marL="60960" marR="60960" marT="30480" marB="30480" anchor="ctr">
+                    <a:lnL w="12700" cap="flat" cmpd="sng" algn="ctr">
+                      <a:noFill/>
+                      <a:prstDash val="solid"/>
+                      <a:round/>
+                      <a:headEnd type="none" w="med" len="med"/>
+                      <a:tailEnd type="none" w="med" len="med"/>
+                    </a:lnL>
+                    <a:lnR w="12700" cap="flat" cmpd="sng" algn="ctr">
+                      <a:noFill/>
+                      <a:prstDash val="solid"/>
+                      <a:round/>
+                      <a:headEnd type="none" w="med" len="med"/>
+                      <a:tailEnd type="none" w="med" len="med"/>
+                    </a:lnR>
+                    <a:lnT w="12700" cap="flat" cmpd="sng" algn="ctr">
+                      <a:noFill/>
+                      <a:prstDash val="solid"/>
+                      <a:round/>
+                      <a:headEnd type="none" w="med" len="med"/>
+                      <a:tailEnd type="none" w="med" len="med"/>
+                    </a:lnT>
+                    <a:lnB w="12700" cap="flat" cmpd="sng" algn="ctr">
+                      <a:noFill/>
+                      <a:prstDash val="solid"/>
+                      <a:round/>
+                      <a:headEnd type="none" w="med" len="med"/>
+                      <a:tailEnd type="none" w="med" len="med"/>
+                    </a:lnB>
+                    <a:solidFill>
+                      <a:schemeClr val="tx1"/>
+                    </a:solidFill>
+                  </a:tcPr>
+                </a:tc>
+                <a:extLst>
+                  <a:ext uri="{0D108BD9-81ED-4DB2-BD59-A6C34878D82A}">
+                    <a16:rowId xmlns:a16="http://schemas.microsoft.com/office/drawing/2014/main" val="1205813917"/>
+                  </a:ext>
+                </a:extLst>
+              </a:tr>
+              <a:tr h="287386">
+                <a:tc>
+                  <a:txBody>
+                    <a:bodyPr/>
+                    <a:lstStyle/>
+                    <a:p>
+                      <a:pPr algn="l" fontAlgn="ctr">
+                        <a:buNone/>
+                      </a:pPr>
+                      <a:r>
+                        <a:rPr lang="en-IL" sz="1050" b="0" i="0" dirty="0">
+                          <a:solidFill>
+                            <a:schemeClr val="bg1"/>
+                          </a:solidFill>
+                          <a:effectLst/>
+                          <a:latin typeface="Segoe WPC"/>
+                        </a:rPr>
+                        <a:t>2018-04-11 22:33:00</a:t>
+                      </a:r>
+                    </a:p>
+                  </a:txBody>
+                  <a:tcPr marL="60960" marR="60960" marT="30480" marB="30480" anchor="ctr">
+                    <a:lnL w="12700" cap="flat" cmpd="sng" algn="ctr">
+                      <a:noFill/>
+                      <a:prstDash val="solid"/>
+                      <a:round/>
+                      <a:headEnd type="none" w="med" len="med"/>
+                      <a:tailEnd type="none" w="med" len="med"/>
+                    </a:lnL>
+                    <a:lnR w="12700" cap="flat" cmpd="sng" algn="ctr">
+                      <a:noFill/>
+                      <a:prstDash val="solid"/>
+                      <a:round/>
+                      <a:headEnd type="none" w="med" len="med"/>
+                      <a:tailEnd type="none" w="med" len="med"/>
+                    </a:lnR>
+                    <a:lnT w="12700" cap="flat" cmpd="sng" algn="ctr">
+                      <a:noFill/>
+                      <a:prstDash val="solid"/>
+                      <a:round/>
+                      <a:headEnd type="none" w="med" len="med"/>
+                      <a:tailEnd type="none" w="med" len="med"/>
+                    </a:lnT>
+                    <a:lnB w="12700" cap="flat" cmpd="sng" algn="ctr">
+                      <a:noFill/>
+                      <a:prstDash val="solid"/>
+                      <a:round/>
+                      <a:headEnd type="none" w="med" len="med"/>
+                      <a:tailEnd type="none" w="med" len="med"/>
+                    </a:lnB>
+                    <a:solidFill>
+                      <a:schemeClr val="tx1"/>
+                    </a:solidFill>
+                  </a:tcPr>
+                </a:tc>
+                <a:tc>
+                  <a:txBody>
+                    <a:bodyPr/>
+                    <a:lstStyle/>
+                    <a:p>
+                      <a:pPr algn="l" fontAlgn="ctr">
+                        <a:buNone/>
+                      </a:pPr>
+                      <a:r>
+                        <a:rPr lang="en-IL" sz="1050" b="0" i="0">
+                          <a:solidFill>
+                            <a:schemeClr val="bg1"/>
+                          </a:solidFill>
+                          <a:effectLst/>
+                          <a:latin typeface="Segoe WPC"/>
+                        </a:rPr>
+                        <a:t>1.480074</a:t>
+                      </a:r>
+                    </a:p>
+                  </a:txBody>
+                  <a:tcPr marL="60960" marR="60960" marT="30480" marB="30480" anchor="ctr">
+                    <a:lnL w="12700" cap="flat" cmpd="sng" algn="ctr">
+                      <a:noFill/>
+                      <a:prstDash val="solid"/>
+                      <a:round/>
+                      <a:headEnd type="none" w="med" len="med"/>
+                      <a:tailEnd type="none" w="med" len="med"/>
+                    </a:lnL>
+                    <a:lnR w="12700" cap="flat" cmpd="sng" algn="ctr">
+                      <a:noFill/>
+                      <a:prstDash val="solid"/>
+                      <a:round/>
+                      <a:headEnd type="none" w="med" len="med"/>
+                      <a:tailEnd type="none" w="med" len="med"/>
+                    </a:lnR>
+                    <a:lnT w="12700" cap="flat" cmpd="sng" algn="ctr">
+                      <a:noFill/>
+                      <a:prstDash val="solid"/>
+                      <a:round/>
+                      <a:headEnd type="none" w="med" len="med"/>
+                      <a:tailEnd type="none" w="med" len="med"/>
+                    </a:lnT>
+                    <a:lnB w="12700" cap="flat" cmpd="sng" algn="ctr">
+                      <a:noFill/>
+                      <a:prstDash val="solid"/>
+                      <a:round/>
+                      <a:headEnd type="none" w="med" len="med"/>
+                      <a:tailEnd type="none" w="med" len="med"/>
+                    </a:lnB>
+                    <a:solidFill>
+                      <a:schemeClr val="tx1"/>
+                    </a:solidFill>
+                  </a:tcPr>
+                </a:tc>
+                <a:tc>
+                  <a:txBody>
+                    <a:bodyPr/>
+                    <a:lstStyle/>
+                    <a:p>
+                      <a:pPr algn="l" fontAlgn="ctr">
+                        <a:buNone/>
+                      </a:pPr>
+                      <a:r>
+                        <a:rPr lang="en-IL" sz="1050" b="0" i="0" dirty="0">
+                          <a:solidFill>
+                            <a:schemeClr val="bg1"/>
+                          </a:solidFill>
+                          <a:effectLst/>
+                          <a:latin typeface="Segoe WPC"/>
+                        </a:rPr>
+                        <a:t>wheels mayor </a:t>
+                      </a:r>
+                    </a:p>
+                  </a:txBody>
+                  <a:tcPr marL="60960" marR="60960" marT="30480" marB="30480" anchor="ctr">
+                    <a:lnL w="12700" cap="flat" cmpd="sng" algn="ctr">
+                      <a:noFill/>
+                      <a:prstDash val="solid"/>
+                      <a:round/>
+                      <a:headEnd type="none" w="med" len="med"/>
+                      <a:tailEnd type="none" w="med" len="med"/>
+                    </a:lnL>
+                    <a:lnR w="12700" cap="flat" cmpd="sng" algn="ctr">
+                      <a:noFill/>
+                      <a:prstDash val="solid"/>
+                      <a:round/>
+                      <a:headEnd type="none" w="med" len="med"/>
+                      <a:tailEnd type="none" w="med" len="med"/>
+                    </a:lnR>
+                    <a:lnT w="12700" cap="flat" cmpd="sng" algn="ctr">
+                      <a:noFill/>
+                      <a:prstDash val="solid"/>
+                      <a:round/>
+                      <a:headEnd type="none" w="med" len="med"/>
+                      <a:tailEnd type="none" w="med" len="med"/>
+                    </a:lnT>
+                    <a:lnB w="12700" cap="flat" cmpd="sng" algn="ctr">
+                      <a:noFill/>
+                      <a:prstDash val="solid"/>
+                      <a:round/>
+                      <a:headEnd type="none" w="med" len="med"/>
+                      <a:tailEnd type="none" w="med" len="med"/>
+                    </a:lnB>
+                    <a:solidFill>
+                      <a:schemeClr val="tx1"/>
+                    </a:solidFill>
+                  </a:tcPr>
+                </a:tc>
+                <a:extLst>
+                  <a:ext uri="{0D108BD9-81ED-4DB2-BD59-A6C34878D82A}">
+                    <a16:rowId xmlns:a16="http://schemas.microsoft.com/office/drawing/2014/main" val="28303785"/>
+                  </a:ext>
+                </a:extLst>
+              </a:tr>
+              <a:tr h="703600">
+                <a:tc>
+                  <a:txBody>
+                    <a:bodyPr/>
+                    <a:lstStyle/>
+                    <a:p>
+                      <a:pPr algn="l" fontAlgn="ctr">
+                        <a:buNone/>
+                      </a:pPr>
+                      <a:r>
+                        <a:rPr lang="en-IL" sz="1050" b="0" i="0" dirty="0">
+                          <a:solidFill>
+                            <a:schemeClr val="bg1"/>
+                          </a:solidFill>
+                          <a:effectLst/>
+                          <a:latin typeface="Segoe WPC"/>
+                        </a:rPr>
+                        <a:t>2018-04-12 02:02:00</a:t>
+                      </a:r>
+                    </a:p>
+                  </a:txBody>
+                  <a:tcPr marL="60960" marR="60960" marT="30480" marB="30480" anchor="ctr">
+                    <a:lnL w="12700" cap="flat" cmpd="sng" algn="ctr">
+                      <a:noFill/>
+                      <a:prstDash val="solid"/>
+                      <a:round/>
+                      <a:headEnd type="none" w="med" len="med"/>
+                      <a:tailEnd type="none" w="med" len="med"/>
+                    </a:lnL>
+                    <a:lnR w="12700" cap="flat" cmpd="sng" algn="ctr">
+                      <a:noFill/>
+                      <a:prstDash val="solid"/>
+                      <a:round/>
+                      <a:headEnd type="none" w="med" len="med"/>
+                      <a:tailEnd type="none" w="med" len="med"/>
+                    </a:lnR>
+                    <a:lnT w="12700" cap="flat" cmpd="sng" algn="ctr">
+                      <a:noFill/>
+                      <a:prstDash val="solid"/>
+                      <a:round/>
+                      <a:headEnd type="none" w="med" len="med"/>
+                      <a:tailEnd type="none" w="med" len="med"/>
+                    </a:lnT>
+                    <a:lnB w="12700" cap="flat" cmpd="sng" algn="ctr">
+                      <a:noFill/>
+                      <a:prstDash val="solid"/>
+                      <a:round/>
+                      <a:headEnd type="none" w="med" len="med"/>
+                      <a:tailEnd type="none" w="med" len="med"/>
+                    </a:lnB>
+                    <a:solidFill>
+                      <a:schemeClr val="tx1"/>
+                    </a:solidFill>
+                  </a:tcPr>
+                </a:tc>
+                <a:tc>
+                  <a:txBody>
+                    <a:bodyPr/>
+                    <a:lstStyle/>
+                    <a:p>
+                      <a:pPr algn="l" fontAlgn="ctr">
+                        <a:buNone/>
+                      </a:pPr>
+                      <a:r>
+                        <a:rPr lang="en-IL" sz="1050" b="0" i="0" dirty="0">
+                          <a:solidFill>
+                            <a:schemeClr val="bg1"/>
+                          </a:solidFill>
+                          <a:effectLst/>
+                          <a:latin typeface="Segoe WPC"/>
+                        </a:rPr>
+                        <a:t>0.788076</a:t>
+                      </a:r>
+                    </a:p>
+                  </a:txBody>
+                  <a:tcPr marL="60960" marR="60960" marT="30480" marB="30480" anchor="ctr">
+                    <a:lnL w="12700" cap="flat" cmpd="sng" algn="ctr">
+                      <a:noFill/>
+                      <a:prstDash val="solid"/>
+                      <a:round/>
+                      <a:headEnd type="none" w="med" len="med"/>
+                      <a:tailEnd type="none" w="med" len="med"/>
+                    </a:lnL>
+                    <a:lnR w="12700" cap="flat" cmpd="sng" algn="ctr">
+                      <a:noFill/>
+                      <a:prstDash val="solid"/>
+                      <a:round/>
+                      <a:headEnd type="none" w="med" len="med"/>
+                      <a:tailEnd type="none" w="med" len="med"/>
+                    </a:lnR>
+                    <a:lnT w="12700" cap="flat" cmpd="sng" algn="ctr">
+                      <a:noFill/>
+                      <a:prstDash val="solid"/>
+                      <a:round/>
+                      <a:headEnd type="none" w="med" len="med"/>
+                      <a:tailEnd type="none" w="med" len="med"/>
+                    </a:lnT>
+                    <a:lnB w="12700" cap="flat" cmpd="sng" algn="ctr">
+                      <a:noFill/>
+                      <a:prstDash val="solid"/>
+                      <a:round/>
+                      <a:headEnd type="none" w="med" len="med"/>
+                      <a:tailEnd type="none" w="med" len="med"/>
+                    </a:lnB>
+                    <a:solidFill>
+                      <a:schemeClr val="tx1"/>
+                    </a:solidFill>
+                  </a:tcPr>
+                </a:tc>
+                <a:tc>
+                  <a:txBody>
+                    <a:bodyPr/>
+                    <a:lstStyle/>
+                    <a:p>
+                      <a:pPr algn="l" fontAlgn="ctr">
+                        <a:buNone/>
+                      </a:pPr>
+                      <a:r>
+                        <a:rPr lang="en-IL" sz="1050" b="0" i="0" dirty="0">
+                          <a:solidFill>
+                            <a:schemeClr val="bg1"/>
+                          </a:solidFill>
+                          <a:effectLst/>
+                          <a:latin typeface="Segoe WPC"/>
+                        </a:rPr>
+                        <a:t>90' + 3' </a:t>
+                      </a:r>
+                      <a:r>
+                        <a:rPr lang="en-IL" sz="1050" b="0" i="0" dirty="0" err="1">
+                          <a:solidFill>
+                            <a:schemeClr val="bg1"/>
+                          </a:solidFill>
+                          <a:effectLst/>
+                          <a:latin typeface="Segoe WPC"/>
+                        </a:rPr>
+                        <a:t>yesssssssss</a:t>
+                      </a:r>
+                      <a:r>
+                        <a:rPr lang="en-IL" sz="1050" b="0" i="0" dirty="0">
+                          <a:solidFill>
+                            <a:schemeClr val="bg1"/>
+                          </a:solidFill>
+                          <a:effectLst/>
+                          <a:latin typeface="Segoe WPC"/>
+                        </a:rPr>
+                        <a:t>!!! scores point view!!! </a:t>
+                      </a:r>
+                      <a:r>
+                        <a:rPr lang="en-IL" sz="1050" b="0" i="0" dirty="0" err="1">
+                          <a:solidFill>
+                            <a:schemeClr val="bg1"/>
+                          </a:solidFill>
+                          <a:effectLst/>
+                          <a:latin typeface="Segoe WPC"/>
+                        </a:rPr>
+                        <a:t>realmadrid</a:t>
+                      </a:r>
+                      <a:r>
+                        <a:rPr lang="en-IL" sz="1050" b="0" i="0" dirty="0">
+                          <a:solidFill>
+                            <a:schemeClr val="bg1"/>
+                          </a:solidFill>
+                          <a:effectLst/>
+                          <a:latin typeface="Segoe WPC"/>
+                        </a:rPr>
+                        <a:t> 1-3 (added 4-3) </a:t>
+                      </a:r>
+                      <a:r>
+                        <a:rPr lang="en-IL" sz="1050" b="0" i="0" dirty="0" err="1">
+                          <a:solidFill>
+                            <a:schemeClr val="bg1"/>
+                          </a:solidFill>
+                          <a:effectLst/>
+                          <a:latin typeface="Segoe WPC"/>
+                        </a:rPr>
+                        <a:t>rmucl</a:t>
+                      </a:r>
+                      <a:r>
+                        <a:rPr lang="en-IL" sz="1050" b="0" i="0" dirty="0">
+                          <a:solidFill>
+                            <a:schemeClr val="bg1"/>
+                          </a:solidFill>
+                          <a:effectLst/>
+                          <a:latin typeface="Segoe WPC"/>
+                        </a:rPr>
+                        <a:t> ▷ aporla13 </a:t>
+                      </a:r>
+                    </a:p>
+                  </a:txBody>
+                  <a:tcPr marL="60960" marR="60960" marT="30480" marB="30480" anchor="ctr">
+                    <a:lnL w="12700" cap="flat" cmpd="sng" algn="ctr">
+                      <a:noFill/>
+                      <a:prstDash val="solid"/>
+                      <a:round/>
+                      <a:headEnd type="none" w="med" len="med"/>
+                      <a:tailEnd type="none" w="med" len="med"/>
+                    </a:lnL>
+                    <a:lnR w="12700" cap="flat" cmpd="sng" algn="ctr">
+                      <a:noFill/>
+                      <a:prstDash val="solid"/>
+                      <a:round/>
+                      <a:headEnd type="none" w="med" len="med"/>
+                      <a:tailEnd type="none" w="med" len="med"/>
+                    </a:lnR>
+                    <a:lnT w="12700" cap="flat" cmpd="sng" algn="ctr">
+                      <a:noFill/>
+                      <a:prstDash val="solid"/>
+                      <a:round/>
+                      <a:headEnd type="none" w="med" len="med"/>
+                      <a:tailEnd type="none" w="med" len="med"/>
+                    </a:lnT>
+                    <a:lnB w="12700" cap="flat" cmpd="sng" algn="ctr">
+                      <a:noFill/>
+                      <a:prstDash val="solid"/>
+                      <a:round/>
+                      <a:headEnd type="none" w="med" len="med"/>
+                      <a:tailEnd type="none" w="med" len="med"/>
+                    </a:lnB>
+                    <a:solidFill>
+                      <a:schemeClr val="tx1"/>
+                    </a:solidFill>
+                  </a:tcPr>
+                </a:tc>
+                <a:extLst>
+                  <a:ext uri="{0D108BD9-81ED-4DB2-BD59-A6C34878D82A}">
+                    <a16:rowId xmlns:a16="http://schemas.microsoft.com/office/drawing/2014/main" val="3685300466"/>
+                  </a:ext>
+                </a:extLst>
+              </a:tr>
+            </a:tbl>
+          </a:graphicData>
+        </a:graphic>
+      </p:graphicFrame>
+      <p:graphicFrame>
+        <p:nvGraphicFramePr>
+          <p:cNvPr id="11" name="Table 10">
+            <a:extLst>
+              <a:ext uri="{FF2B5EF4-FFF2-40B4-BE49-F238E27FC236}">
+                <a16:creationId xmlns:a16="http://schemas.microsoft.com/office/drawing/2014/main" id="{465C3474-036B-52AB-5CE7-B53DFED13014}"/>
+              </a:ext>
+            </a:extLst>
+          </p:cNvPr>
+          <p:cNvGraphicFramePr>
+            <a:graphicFrameLocks noGrp="1"/>
+          </p:cNvGraphicFramePr>
+          <p:nvPr>
+            <p:extLst>
+              <p:ext uri="{D42A27DB-BD31-4B8C-83A1-F6EECF244321}">
+                <p14:modId xmlns:p14="http://schemas.microsoft.com/office/powerpoint/2010/main" val="4190037539"/>
+              </p:ext>
+            </p:extLst>
+          </p:nvPr>
+        </p:nvGraphicFramePr>
+        <p:xfrm>
+          <a:off x="6523549" y="4212265"/>
+          <a:ext cx="5232287" cy="2125980"/>
+        </p:xfrm>
+        <a:graphic>
+          <a:graphicData uri="http://schemas.openxmlformats.org/drawingml/2006/table">
+            <a:tbl>
+              <a:tblPr/>
+              <a:tblGrid>
+                <a:gridCol w="1169050">
+                  <a:extLst>
+                    <a:ext uri="{9D8B030D-6E8A-4147-A177-3AD203B41FA5}">
+                      <a16:colId xmlns:a16="http://schemas.microsoft.com/office/drawing/2014/main" val="3764125448"/>
+                    </a:ext>
+                  </a:extLst>
+                </a:gridCol>
+                <a:gridCol w="730235">
+                  <a:extLst>
+                    <a:ext uri="{9D8B030D-6E8A-4147-A177-3AD203B41FA5}">
+                      <a16:colId xmlns:a16="http://schemas.microsoft.com/office/drawing/2014/main" val="563687860"/>
+                    </a:ext>
+                  </a:extLst>
+                </a:gridCol>
+                <a:gridCol w="3333002">
+                  <a:extLst>
+                    <a:ext uri="{9D8B030D-6E8A-4147-A177-3AD203B41FA5}">
+                      <a16:colId xmlns:a16="http://schemas.microsoft.com/office/drawing/2014/main" val="1202269014"/>
+                    </a:ext>
+                  </a:extLst>
+                </a:gridCol>
+              </a:tblGrid>
+              <a:tr h="194450">
+                <a:tc>
+                  <a:txBody>
+                    <a:bodyPr/>
+                    <a:lstStyle/>
+                    <a:p>
+                      <a:pPr algn="l" fontAlgn="ctr">
+                        <a:buNone/>
+                      </a:pPr>
+                      <a:r>
+                        <a:rPr lang="en-IL" sz="1050" b="0" i="0" dirty="0" err="1">
+                          <a:solidFill>
+                            <a:schemeClr val="bg1"/>
+                          </a:solidFill>
+                          <a:effectLst/>
+                          <a:latin typeface="Segoe WPC"/>
+                        </a:rPr>
+                        <a:t>post_time</a:t>
+                      </a:r>
+                      <a:endParaRPr lang="en-IL" sz="1050" b="0" i="0" dirty="0">
+                        <a:solidFill>
+                          <a:schemeClr val="bg1"/>
+                        </a:solidFill>
+                        <a:effectLst/>
+                        <a:latin typeface="Segoe WPC"/>
+                      </a:endParaRPr>
+                    </a:p>
+                  </a:txBody>
+                  <a:tcPr marL="60960" marR="60960" marT="30480" marB="30480" anchor="ctr">
+                    <a:lnL w="12700" cap="flat" cmpd="sng" algn="ctr">
+                      <a:noFill/>
+                      <a:prstDash val="solid"/>
+                      <a:round/>
+                      <a:headEnd type="none" w="med" len="med"/>
+                      <a:tailEnd type="none" w="med" len="med"/>
+                    </a:lnL>
+                    <a:lnR w="12700" cap="flat" cmpd="sng" algn="ctr">
+                      <a:noFill/>
+                      <a:prstDash val="solid"/>
+                      <a:round/>
+                      <a:headEnd type="none" w="med" len="med"/>
+                      <a:tailEnd type="none" w="med" len="med"/>
+                    </a:lnR>
+                    <a:lnT w="12700" cap="flat" cmpd="sng" algn="ctr">
+                      <a:noFill/>
+                      <a:prstDash val="solid"/>
+                      <a:round/>
+                      <a:headEnd type="none" w="med" len="med"/>
+                      <a:tailEnd type="none" w="med" len="med"/>
+                    </a:lnT>
+                    <a:lnB w="12700" cap="flat" cmpd="sng" algn="ctr">
+                      <a:noFill/>
+                      <a:prstDash val="solid"/>
+                      <a:round/>
+                      <a:headEnd type="none" w="med" len="med"/>
+                      <a:tailEnd type="none" w="med" len="med"/>
+                    </a:lnB>
+                    <a:solidFill>
+                      <a:schemeClr val="tx1"/>
+                    </a:solidFill>
+                  </a:tcPr>
+                </a:tc>
+                <a:tc>
+                  <a:txBody>
+                    <a:bodyPr/>
+                    <a:lstStyle/>
+                    <a:p>
+                      <a:pPr algn="l" fontAlgn="ctr">
+                        <a:buNone/>
+                      </a:pPr>
+                      <a:r>
+                        <a:rPr lang="en-IL" sz="1050" b="0" i="0" dirty="0" err="1">
+                          <a:solidFill>
+                            <a:schemeClr val="bg1"/>
+                          </a:solidFill>
+                          <a:effectLst/>
+                          <a:latin typeface="Segoe WPC"/>
+                        </a:rPr>
+                        <a:t>post_tfidf</a:t>
+                      </a:r>
+                      <a:endParaRPr lang="en-IL" sz="1050" b="0" i="0" dirty="0">
+                        <a:solidFill>
+                          <a:schemeClr val="bg1"/>
+                        </a:solidFill>
+                        <a:effectLst/>
+                        <a:latin typeface="Segoe WPC"/>
+                      </a:endParaRPr>
+                    </a:p>
+                  </a:txBody>
+                  <a:tcPr marL="60960" marR="60960" marT="30480" marB="30480" anchor="ctr">
+                    <a:lnL w="12700" cap="flat" cmpd="sng" algn="ctr">
+                      <a:noFill/>
+                      <a:prstDash val="solid"/>
+                      <a:round/>
+                      <a:headEnd type="none" w="med" len="med"/>
+                      <a:tailEnd type="none" w="med" len="med"/>
+                    </a:lnL>
+                    <a:lnR w="12700" cap="flat" cmpd="sng" algn="ctr">
+                      <a:noFill/>
+                      <a:prstDash val="solid"/>
+                      <a:round/>
+                      <a:headEnd type="none" w="med" len="med"/>
+                      <a:tailEnd type="none" w="med" len="med"/>
+                    </a:lnR>
+                    <a:lnT w="12700" cap="flat" cmpd="sng" algn="ctr">
+                      <a:noFill/>
+                      <a:prstDash val="solid"/>
+                      <a:round/>
+                      <a:headEnd type="none" w="med" len="med"/>
+                      <a:tailEnd type="none" w="med" len="med"/>
+                    </a:lnT>
+                    <a:lnB w="12700" cap="flat" cmpd="sng" algn="ctr">
+                      <a:noFill/>
+                      <a:prstDash val="solid"/>
+                      <a:round/>
+                      <a:headEnd type="none" w="med" len="med"/>
+                      <a:tailEnd type="none" w="med" len="med"/>
+                    </a:lnB>
+                    <a:solidFill>
+                      <a:schemeClr val="tx1"/>
+                    </a:solidFill>
+                  </a:tcPr>
+                </a:tc>
+                <a:tc>
+                  <a:txBody>
+                    <a:bodyPr/>
+                    <a:lstStyle/>
+                    <a:p>
+                      <a:pPr algn="l" fontAlgn="ctr">
+                        <a:buNone/>
+                      </a:pPr>
+                      <a:r>
+                        <a:rPr lang="en-IL" sz="1050" b="0" i="0" dirty="0" err="1">
+                          <a:solidFill>
+                            <a:schemeClr val="bg1"/>
+                          </a:solidFill>
+                          <a:effectLst/>
+                          <a:latin typeface="Segoe WPC"/>
+                        </a:rPr>
+                        <a:t>translated_post</a:t>
+                      </a:r>
+                      <a:endParaRPr lang="en-IL" sz="1050" b="0" i="0" dirty="0">
+                        <a:solidFill>
+                          <a:schemeClr val="bg1"/>
+                        </a:solidFill>
+                        <a:effectLst/>
+                        <a:latin typeface="Segoe WPC"/>
+                      </a:endParaRPr>
+                    </a:p>
+                  </a:txBody>
+                  <a:tcPr marL="60960" marR="60960" marT="30480" marB="30480" anchor="ctr">
+                    <a:lnL w="12700" cap="flat" cmpd="sng" algn="ctr">
+                      <a:noFill/>
+                      <a:prstDash val="solid"/>
+                      <a:round/>
+                      <a:headEnd type="none" w="med" len="med"/>
+                      <a:tailEnd type="none" w="med" len="med"/>
+                    </a:lnL>
+                    <a:lnR w="12700" cap="flat" cmpd="sng" algn="ctr">
+                      <a:noFill/>
+                      <a:prstDash val="solid"/>
+                      <a:round/>
+                      <a:headEnd type="none" w="med" len="med"/>
+                      <a:tailEnd type="none" w="med" len="med"/>
+                    </a:lnR>
+                    <a:lnT w="12700" cap="flat" cmpd="sng" algn="ctr">
+                      <a:noFill/>
+                      <a:prstDash val="solid"/>
+                      <a:round/>
+                      <a:headEnd type="none" w="med" len="med"/>
+                      <a:tailEnd type="none" w="med" len="med"/>
+                    </a:lnT>
+                    <a:lnB w="12700" cap="flat" cmpd="sng" algn="ctr">
+                      <a:noFill/>
+                      <a:prstDash val="solid"/>
+                      <a:round/>
+                      <a:headEnd type="none" w="med" len="med"/>
+                      <a:tailEnd type="none" w="med" len="med"/>
+                    </a:lnB>
+                    <a:solidFill>
+                      <a:schemeClr val="tx1"/>
+                    </a:solidFill>
+                  </a:tcPr>
+                </a:tc>
+                <a:extLst>
+                  <a:ext uri="{0D108BD9-81ED-4DB2-BD59-A6C34878D82A}">
+                    <a16:rowId xmlns:a16="http://schemas.microsoft.com/office/drawing/2014/main" val="488294037"/>
+                  </a:ext>
+                </a:extLst>
+              </a:tr>
+              <a:tr h="367301">
+                <a:tc>
+                  <a:txBody>
+                    <a:bodyPr/>
+                    <a:lstStyle/>
+                    <a:p>
+                      <a:pPr algn="l" fontAlgn="ctr">
+                        <a:buNone/>
+                      </a:pPr>
+                      <a:r>
+                        <a:rPr lang="en-IL" sz="1050" b="0" i="0">
+                          <a:solidFill>
+                            <a:schemeClr val="bg1"/>
+                          </a:solidFill>
+                          <a:effectLst/>
+                          <a:latin typeface="Segoe WPC"/>
+                        </a:rPr>
+                        <a:t>2018-04-12 02:01:00</a:t>
+                      </a:r>
+                    </a:p>
+                  </a:txBody>
+                  <a:tcPr marL="60960" marR="60960" marT="30480" marB="30480" anchor="ctr">
+                    <a:lnL w="12700" cap="flat" cmpd="sng" algn="ctr">
+                      <a:noFill/>
+                      <a:prstDash val="solid"/>
+                      <a:round/>
+                      <a:headEnd type="none" w="med" len="med"/>
+                      <a:tailEnd type="none" w="med" len="med"/>
+                    </a:lnL>
+                    <a:lnR w="12700" cap="flat" cmpd="sng" algn="ctr">
+                      <a:noFill/>
+                      <a:prstDash val="solid"/>
+                      <a:round/>
+                      <a:headEnd type="none" w="med" len="med"/>
+                      <a:tailEnd type="none" w="med" len="med"/>
+                    </a:lnR>
+                    <a:lnT w="12700" cap="flat" cmpd="sng" algn="ctr">
+                      <a:noFill/>
+                      <a:prstDash val="solid"/>
+                      <a:round/>
+                      <a:headEnd type="none" w="med" len="med"/>
+                      <a:tailEnd type="none" w="med" len="med"/>
+                    </a:lnT>
+                    <a:lnB w="12700" cap="flat" cmpd="sng" algn="ctr">
+                      <a:noFill/>
+                      <a:prstDash val="solid"/>
+                      <a:round/>
+                      <a:headEnd type="none" w="med" len="med"/>
+                      <a:tailEnd type="none" w="med" len="med"/>
+                    </a:lnB>
+                    <a:solidFill>
+                      <a:schemeClr val="tx1"/>
+                    </a:solidFill>
+                  </a:tcPr>
+                </a:tc>
+                <a:tc>
+                  <a:txBody>
+                    <a:bodyPr/>
+                    <a:lstStyle/>
+                    <a:p>
+                      <a:pPr algn="l" fontAlgn="ctr">
+                        <a:buNone/>
+                      </a:pPr>
+                      <a:r>
+                        <a:rPr lang="en-IL" sz="1050" b="0" i="0" dirty="0">
+                          <a:solidFill>
+                            <a:schemeClr val="bg1"/>
+                          </a:solidFill>
+                          <a:effectLst/>
+                          <a:latin typeface="Segoe WPC"/>
+                        </a:rPr>
+                        <a:t>0.788076</a:t>
+                      </a:r>
+                    </a:p>
+                  </a:txBody>
+                  <a:tcPr marL="60960" marR="60960" marT="30480" marB="30480" anchor="ctr">
+                    <a:lnL w="12700" cap="flat" cmpd="sng" algn="ctr">
+                      <a:noFill/>
+                      <a:prstDash val="solid"/>
+                      <a:round/>
+                      <a:headEnd type="none" w="med" len="med"/>
+                      <a:tailEnd type="none" w="med" len="med"/>
+                    </a:lnL>
+                    <a:lnR w="12700" cap="flat" cmpd="sng" algn="ctr">
+                      <a:noFill/>
+                      <a:prstDash val="solid"/>
+                      <a:round/>
+                      <a:headEnd type="none" w="med" len="med"/>
+                      <a:tailEnd type="none" w="med" len="med"/>
+                    </a:lnR>
+                    <a:lnT w="12700" cap="flat" cmpd="sng" algn="ctr">
+                      <a:noFill/>
+                      <a:prstDash val="solid"/>
+                      <a:round/>
+                      <a:headEnd type="none" w="med" len="med"/>
+                      <a:tailEnd type="none" w="med" len="med"/>
+                    </a:lnT>
+                    <a:lnB w="12700" cap="flat" cmpd="sng" algn="ctr">
+                      <a:noFill/>
+                      <a:prstDash val="solid"/>
+                      <a:round/>
+                      <a:headEnd type="none" w="med" len="med"/>
+                      <a:tailEnd type="none" w="med" len="med"/>
+                    </a:lnB>
+                    <a:lnTlToBr w="12700" cmpd="sng">
+                      <a:noFill/>
+                      <a:prstDash val="solid"/>
+                    </a:lnTlToBr>
+                    <a:lnBlToTr w="12700" cmpd="sng">
+                      <a:noFill/>
+                      <a:prstDash val="solid"/>
+                    </a:lnBlToTr>
+                    <a:solidFill>
+                      <a:schemeClr val="tx1"/>
+                    </a:solidFill>
+                  </a:tcPr>
+                </a:tc>
+                <a:tc>
+                  <a:txBody>
+                    <a:bodyPr/>
+                    <a:lstStyle/>
+                    <a:p>
+                      <a:pPr algn="l" fontAlgn="ctr">
+                        <a:buNone/>
+                      </a:pPr>
+                      <a:r>
+                        <a:rPr lang="en-IL" sz="1050" b="0" i="0" dirty="0">
+                          <a:solidFill>
+                            <a:schemeClr val="bg1"/>
+                          </a:solidFill>
+                          <a:effectLst/>
+                          <a:latin typeface="Segoe WPC"/>
+                        </a:rPr>
+                        <a:t>90' + 3' </a:t>
+                      </a:r>
+                      <a:r>
+                        <a:rPr lang="en-IL" sz="1050" b="0" i="0" dirty="0" err="1">
+                          <a:solidFill>
+                            <a:schemeClr val="bg1"/>
+                          </a:solidFill>
+                          <a:effectLst/>
+                          <a:latin typeface="Segoe WPC"/>
+                        </a:rPr>
+                        <a:t>yesssssssss</a:t>
+                      </a:r>
+                      <a:r>
+                        <a:rPr lang="en-IL" sz="1050" b="0" i="0" dirty="0">
+                          <a:solidFill>
+                            <a:schemeClr val="bg1"/>
+                          </a:solidFill>
+                          <a:effectLst/>
+                          <a:latin typeface="Segoe WPC"/>
+                        </a:rPr>
+                        <a:t>!!! scores point view!!! </a:t>
+                      </a:r>
+                      <a:r>
+                        <a:rPr lang="en-IL" sz="1050" b="0" i="0" dirty="0" err="1">
+                          <a:solidFill>
+                            <a:schemeClr val="bg1"/>
+                          </a:solidFill>
+                          <a:effectLst/>
+                          <a:latin typeface="Segoe WPC"/>
+                        </a:rPr>
+                        <a:t>realmadrid</a:t>
+                      </a:r>
+                      <a:r>
+                        <a:rPr lang="en-IL" sz="1050" b="0" i="0" dirty="0">
+                          <a:solidFill>
+                            <a:schemeClr val="bg1"/>
+                          </a:solidFill>
+                          <a:effectLst/>
+                          <a:latin typeface="Segoe WPC"/>
+                        </a:rPr>
+                        <a:t> 1-3 (added 4-3) </a:t>
+                      </a:r>
+                      <a:r>
+                        <a:rPr lang="en-IL" sz="1050" b="0" i="0" dirty="0" err="1">
+                          <a:solidFill>
+                            <a:schemeClr val="bg1"/>
+                          </a:solidFill>
+                          <a:effectLst/>
+                          <a:latin typeface="Segoe WPC"/>
+                        </a:rPr>
+                        <a:t>rmucl</a:t>
+                      </a:r>
+                      <a:r>
+                        <a:rPr lang="en-IL" sz="1050" b="0" i="0" dirty="0">
+                          <a:solidFill>
+                            <a:schemeClr val="bg1"/>
+                          </a:solidFill>
+                          <a:effectLst/>
+                          <a:latin typeface="Segoe WPC"/>
+                        </a:rPr>
+                        <a:t> ▷ aporla13 </a:t>
+                      </a:r>
+                    </a:p>
+                  </a:txBody>
+                  <a:tcPr marL="60960" marR="60960" marT="30480" marB="30480" anchor="ctr">
+                    <a:lnL w="12700" cap="flat" cmpd="sng" algn="ctr">
+                      <a:noFill/>
+                      <a:prstDash val="solid"/>
+                      <a:round/>
+                      <a:headEnd type="none" w="med" len="med"/>
+                      <a:tailEnd type="none" w="med" len="med"/>
+                    </a:lnL>
+                    <a:lnR w="12700" cap="flat" cmpd="sng" algn="ctr">
+                      <a:noFill/>
+                      <a:prstDash val="solid"/>
+                      <a:round/>
+                      <a:headEnd type="none" w="med" len="med"/>
+                      <a:tailEnd type="none" w="med" len="med"/>
+                    </a:lnR>
+                    <a:lnT w="12700" cap="flat" cmpd="sng" algn="ctr">
+                      <a:noFill/>
+                      <a:prstDash val="solid"/>
+                      <a:round/>
+                      <a:headEnd type="none" w="med" len="med"/>
+                      <a:tailEnd type="none" w="med" len="med"/>
+                    </a:lnT>
+                    <a:lnB w="12700" cap="flat" cmpd="sng" algn="ctr">
+                      <a:noFill/>
+                      <a:prstDash val="solid"/>
+                      <a:round/>
+                      <a:headEnd type="none" w="med" len="med"/>
+                      <a:tailEnd type="none" w="med" len="med"/>
+                    </a:lnB>
+                    <a:solidFill>
+                      <a:schemeClr val="tx1"/>
+                    </a:solidFill>
+                  </a:tcPr>
+                </a:tc>
+                <a:extLst>
+                  <a:ext uri="{0D108BD9-81ED-4DB2-BD59-A6C34878D82A}">
+                    <a16:rowId xmlns:a16="http://schemas.microsoft.com/office/drawing/2014/main" val="948827448"/>
+                  </a:ext>
+                </a:extLst>
+              </a:tr>
+              <a:tr h="335259">
+                <a:tc>
+                  <a:txBody>
+                    <a:bodyPr/>
+                    <a:lstStyle/>
+                    <a:p>
+                      <a:pPr algn="l" fontAlgn="ctr">
+                        <a:buNone/>
+                      </a:pPr>
+                      <a:r>
+                        <a:rPr lang="en-IL" sz="1050" b="0" i="0">
+                          <a:solidFill>
+                            <a:schemeClr val="bg1"/>
+                          </a:solidFill>
+                          <a:effectLst/>
+                          <a:latin typeface="Segoe WPC"/>
+                        </a:rPr>
+                        <a:t>2018-03-31 12:35:00</a:t>
+                      </a:r>
+                    </a:p>
+                  </a:txBody>
+                  <a:tcPr marL="60960" marR="60960" marT="30480" marB="30480" anchor="ctr">
+                    <a:lnL w="12700" cap="flat" cmpd="sng" algn="ctr">
+                      <a:noFill/>
+                      <a:prstDash val="solid"/>
+                      <a:round/>
+                      <a:headEnd type="none" w="med" len="med"/>
+                      <a:tailEnd type="none" w="med" len="med"/>
+                    </a:lnL>
+                    <a:lnR w="12700" cap="flat" cmpd="sng" algn="ctr">
+                      <a:noFill/>
+                      <a:prstDash val="solid"/>
+                      <a:round/>
+                      <a:headEnd type="none" w="med" len="med"/>
+                      <a:tailEnd type="none" w="med" len="med"/>
+                    </a:lnR>
+                    <a:lnT w="12700" cap="flat" cmpd="sng" algn="ctr">
+                      <a:noFill/>
+                      <a:prstDash val="solid"/>
+                      <a:round/>
+                      <a:headEnd type="none" w="med" len="med"/>
+                      <a:tailEnd type="none" w="med" len="med"/>
+                    </a:lnT>
+                    <a:lnB w="12700" cap="flat" cmpd="sng" algn="ctr">
+                      <a:noFill/>
+                      <a:prstDash val="solid"/>
+                      <a:round/>
+                      <a:headEnd type="none" w="med" len="med"/>
+                      <a:tailEnd type="none" w="med" len="med"/>
+                    </a:lnB>
+                    <a:solidFill>
+                      <a:schemeClr val="tx1"/>
+                    </a:solidFill>
+                  </a:tcPr>
+                </a:tc>
+                <a:tc>
+                  <a:txBody>
+                    <a:bodyPr/>
+                    <a:lstStyle/>
+                    <a:p>
+                      <a:pPr algn="l" fontAlgn="ctr">
+                        <a:buNone/>
+                      </a:pPr>
+                      <a:r>
+                        <a:rPr lang="en-IL" sz="1050" b="0" i="0">
+                          <a:solidFill>
+                            <a:schemeClr val="bg1"/>
+                          </a:solidFill>
+                          <a:effectLst/>
+                          <a:latin typeface="Segoe WPC"/>
+                        </a:rPr>
+                        <a:t>0.529600</a:t>
+                      </a:r>
+                    </a:p>
+                  </a:txBody>
+                  <a:tcPr marL="60960" marR="60960" marT="30480" marB="30480" anchor="ctr">
+                    <a:lnL w="12700" cap="flat" cmpd="sng" algn="ctr">
+                      <a:noFill/>
+                      <a:prstDash val="solid"/>
+                      <a:round/>
+                      <a:headEnd type="none" w="med" len="med"/>
+                      <a:tailEnd type="none" w="med" len="med"/>
+                    </a:lnL>
+                    <a:lnR w="12700" cap="flat" cmpd="sng" algn="ctr">
+                      <a:noFill/>
+                      <a:prstDash val="solid"/>
+                      <a:round/>
+                      <a:headEnd type="none" w="med" len="med"/>
+                      <a:tailEnd type="none" w="med" len="med"/>
+                    </a:lnR>
+                    <a:lnT w="12700" cap="flat" cmpd="sng" algn="ctr">
+                      <a:noFill/>
+                      <a:prstDash val="solid"/>
+                      <a:round/>
+                      <a:headEnd type="none" w="med" len="med"/>
+                      <a:tailEnd type="none" w="med" len="med"/>
+                    </a:lnT>
+                    <a:lnB w="12700" cap="flat" cmpd="sng" algn="ctr">
+                      <a:noFill/>
+                      <a:prstDash val="solid"/>
+                      <a:round/>
+                      <a:headEnd type="none" w="med" len="med"/>
+                      <a:tailEnd type="none" w="med" len="med"/>
+                    </a:lnB>
+                    <a:solidFill>
+                      <a:schemeClr val="tx1"/>
+                    </a:solidFill>
+                  </a:tcPr>
+                </a:tc>
+                <a:tc>
+                  <a:txBody>
+                    <a:bodyPr/>
+                    <a:lstStyle/>
+                    <a:p>
+                      <a:pPr algn="l" fontAlgn="ctr">
+                        <a:buNone/>
+                      </a:pPr>
+                      <a:r>
+                        <a:rPr lang="en-IL" sz="1050" b="0" i="0" dirty="0">
+                          <a:solidFill>
+                            <a:schemeClr val="bg1"/>
+                          </a:solidFill>
+                          <a:effectLst/>
+                          <a:latin typeface="Segoe WPC"/>
+                        </a:rPr>
+                        <a:t>criminals destroying park city aspire daughter mayor... </a:t>
+                      </a:r>
+                    </a:p>
+                  </a:txBody>
+                  <a:tcPr marL="60960" marR="60960" marT="30480" marB="30480" anchor="ctr">
+                    <a:lnL w="12700" cap="flat" cmpd="sng" algn="ctr">
+                      <a:noFill/>
+                      <a:prstDash val="solid"/>
+                      <a:round/>
+                      <a:headEnd type="none" w="med" len="med"/>
+                      <a:tailEnd type="none" w="med" len="med"/>
+                    </a:lnL>
+                    <a:lnR w="12700" cap="flat" cmpd="sng" algn="ctr">
+                      <a:noFill/>
+                      <a:prstDash val="solid"/>
+                      <a:round/>
+                      <a:headEnd type="none" w="med" len="med"/>
+                      <a:tailEnd type="none" w="med" len="med"/>
+                    </a:lnR>
+                    <a:lnT w="12700" cap="flat" cmpd="sng" algn="ctr">
+                      <a:noFill/>
+                      <a:prstDash val="solid"/>
+                      <a:round/>
+                      <a:headEnd type="none" w="med" len="med"/>
+                      <a:tailEnd type="none" w="med" len="med"/>
+                    </a:lnT>
+                    <a:lnB w="12700" cap="flat" cmpd="sng" algn="ctr">
+                      <a:noFill/>
+                      <a:prstDash val="solid"/>
+                      <a:round/>
+                      <a:headEnd type="none" w="med" len="med"/>
+                      <a:tailEnd type="none" w="med" len="med"/>
+                    </a:lnB>
+                    <a:solidFill>
+                      <a:schemeClr val="tx1"/>
+                    </a:solidFill>
+                  </a:tcPr>
+                </a:tc>
+                <a:extLst>
+                  <a:ext uri="{0D108BD9-81ED-4DB2-BD59-A6C34878D82A}">
+                    <a16:rowId xmlns:a16="http://schemas.microsoft.com/office/drawing/2014/main" val="3092621833"/>
+                  </a:ext>
+                </a:extLst>
+              </a:tr>
+              <a:tr h="335259">
+                <a:tc>
+                  <a:txBody>
+                    <a:bodyPr/>
+                    <a:lstStyle/>
+                    <a:p>
+                      <a:pPr algn="l" fontAlgn="ctr">
+                        <a:buNone/>
+                      </a:pPr>
+                      <a:r>
+                        <a:rPr lang="en-IL" sz="1050" b="0" i="0">
+                          <a:solidFill>
+                            <a:schemeClr val="bg1"/>
+                          </a:solidFill>
+                          <a:effectLst/>
+                          <a:latin typeface="Segoe WPC"/>
+                        </a:rPr>
+                        <a:t>2018-03-31 14:35:00</a:t>
+                      </a:r>
+                    </a:p>
+                  </a:txBody>
+                  <a:tcPr marL="60960" marR="60960" marT="30480" marB="30480" anchor="ctr">
+                    <a:lnL w="12700" cap="flat" cmpd="sng" algn="ctr">
+                      <a:noFill/>
+                      <a:prstDash val="solid"/>
+                      <a:round/>
+                      <a:headEnd type="none" w="med" len="med"/>
+                      <a:tailEnd type="none" w="med" len="med"/>
+                    </a:lnL>
+                    <a:lnR w="12700" cap="flat" cmpd="sng" algn="ctr">
+                      <a:noFill/>
+                      <a:prstDash val="solid"/>
+                      <a:round/>
+                      <a:headEnd type="none" w="med" len="med"/>
+                      <a:tailEnd type="none" w="med" len="med"/>
+                    </a:lnR>
+                    <a:lnT w="12700" cap="flat" cmpd="sng" algn="ctr">
+                      <a:noFill/>
+                      <a:prstDash val="solid"/>
+                      <a:round/>
+                      <a:headEnd type="none" w="med" len="med"/>
+                      <a:tailEnd type="none" w="med" len="med"/>
+                    </a:lnT>
+                    <a:lnB w="12700" cap="flat" cmpd="sng" algn="ctr">
+                      <a:noFill/>
+                      <a:prstDash val="solid"/>
+                      <a:round/>
+                      <a:headEnd type="none" w="med" len="med"/>
+                      <a:tailEnd type="none" w="med" len="med"/>
+                    </a:lnB>
+                    <a:solidFill>
+                      <a:schemeClr val="tx1"/>
+                    </a:solidFill>
+                  </a:tcPr>
+                </a:tc>
+                <a:tc>
+                  <a:txBody>
+                    <a:bodyPr/>
+                    <a:lstStyle/>
+                    <a:p>
+                      <a:pPr algn="l" fontAlgn="ctr">
+                        <a:buNone/>
+                      </a:pPr>
+                      <a:r>
+                        <a:rPr lang="en-IL" sz="1050" b="0" i="0" dirty="0">
+                          <a:solidFill>
+                            <a:schemeClr val="bg1"/>
+                          </a:solidFill>
+                          <a:effectLst/>
+                          <a:latin typeface="Segoe WPC"/>
+                        </a:rPr>
+                        <a:t>0.529600</a:t>
+                      </a:r>
+                    </a:p>
+                  </a:txBody>
+                  <a:tcPr marL="60960" marR="60960" marT="30480" marB="30480" anchor="ctr">
+                    <a:lnL w="12700" cap="flat" cmpd="sng" algn="ctr">
+                      <a:noFill/>
+                      <a:prstDash val="solid"/>
+                      <a:round/>
+                      <a:headEnd type="none" w="med" len="med"/>
+                      <a:tailEnd type="none" w="med" len="med"/>
+                    </a:lnL>
+                    <a:lnR w="12700" cap="flat" cmpd="sng" algn="ctr">
+                      <a:noFill/>
+                      <a:prstDash val="solid"/>
+                      <a:round/>
+                      <a:headEnd type="none" w="med" len="med"/>
+                      <a:tailEnd type="none" w="med" len="med"/>
+                    </a:lnR>
+                    <a:lnT w="12700" cap="flat" cmpd="sng" algn="ctr">
+                      <a:noFill/>
+                      <a:prstDash val="solid"/>
+                      <a:round/>
+                      <a:headEnd type="none" w="med" len="med"/>
+                      <a:tailEnd type="none" w="med" len="med"/>
+                    </a:lnT>
+                    <a:lnB w="12700" cap="flat" cmpd="sng" algn="ctr">
+                      <a:noFill/>
+                      <a:prstDash val="solid"/>
+                      <a:round/>
+                      <a:headEnd type="none" w="med" len="med"/>
+                      <a:tailEnd type="none" w="med" len="med"/>
+                    </a:lnB>
+                    <a:solidFill>
+                      <a:schemeClr val="tx1"/>
+                    </a:solidFill>
+                  </a:tcPr>
+                </a:tc>
+                <a:tc>
+                  <a:txBody>
+                    <a:bodyPr/>
+                    <a:lstStyle/>
+                    <a:p>
+                      <a:pPr algn="l" fontAlgn="ctr">
+                        <a:buNone/>
+                      </a:pPr>
+                      <a:r>
+                        <a:rPr lang="en-IL" sz="1050" b="0" i="0" dirty="0">
+                          <a:solidFill>
+                            <a:schemeClr val="bg1"/>
+                          </a:solidFill>
+                          <a:effectLst/>
+                          <a:latin typeface="Segoe WPC"/>
+                        </a:rPr>
+                        <a:t>criminals destroying park city aspire daughter mayor... </a:t>
+                      </a:r>
+                    </a:p>
+                  </a:txBody>
+                  <a:tcPr marL="60960" marR="60960" marT="30480" marB="30480" anchor="ctr">
+                    <a:lnL w="12700" cap="flat" cmpd="sng" algn="ctr">
+                      <a:noFill/>
+                      <a:prstDash val="solid"/>
+                      <a:round/>
+                      <a:headEnd type="none" w="med" len="med"/>
+                      <a:tailEnd type="none" w="med" len="med"/>
+                    </a:lnL>
+                    <a:lnR w="12700" cap="flat" cmpd="sng" algn="ctr">
+                      <a:noFill/>
+                      <a:prstDash val="solid"/>
+                      <a:round/>
+                      <a:headEnd type="none" w="med" len="med"/>
+                      <a:tailEnd type="none" w="med" len="med"/>
+                    </a:lnR>
+                    <a:lnT w="12700" cap="flat" cmpd="sng" algn="ctr">
+                      <a:noFill/>
+                      <a:prstDash val="solid"/>
+                      <a:round/>
+                      <a:headEnd type="none" w="med" len="med"/>
+                      <a:tailEnd type="none" w="med" len="med"/>
+                    </a:lnT>
+                    <a:lnB w="12700" cap="flat" cmpd="sng" algn="ctr">
+                      <a:noFill/>
+                      <a:prstDash val="solid"/>
+                      <a:round/>
+                      <a:headEnd type="none" w="med" len="med"/>
+                      <a:tailEnd type="none" w="med" len="med"/>
+                    </a:lnB>
+                    <a:solidFill>
+                      <a:schemeClr val="tx1"/>
+                    </a:solidFill>
+                  </a:tcPr>
+                </a:tc>
+                <a:extLst>
+                  <a:ext uri="{0D108BD9-81ED-4DB2-BD59-A6C34878D82A}">
+                    <a16:rowId xmlns:a16="http://schemas.microsoft.com/office/drawing/2014/main" val="3557835435"/>
+                  </a:ext>
+                </a:extLst>
+              </a:tr>
+              <a:tr h="335259">
+                <a:tc>
+                  <a:txBody>
+                    <a:bodyPr/>
+                    <a:lstStyle/>
+                    <a:p>
+                      <a:pPr algn="l" fontAlgn="ctr">
+                        <a:buNone/>
+                      </a:pPr>
+                      <a:r>
+                        <a:rPr lang="en-IL" sz="1050" b="0" i="0">
+                          <a:solidFill>
+                            <a:schemeClr val="bg1"/>
+                          </a:solidFill>
+                          <a:effectLst/>
+                          <a:latin typeface="Segoe WPC"/>
+                        </a:rPr>
+                        <a:t>2018-03-18 13:32:00</a:t>
+                      </a:r>
+                    </a:p>
+                  </a:txBody>
+                  <a:tcPr marL="60960" marR="60960" marT="30480" marB="30480" anchor="ctr">
+                    <a:lnL w="12700" cap="flat" cmpd="sng" algn="ctr">
+                      <a:noFill/>
+                      <a:prstDash val="solid"/>
+                      <a:round/>
+                      <a:headEnd type="none" w="med" len="med"/>
+                      <a:tailEnd type="none" w="med" len="med"/>
+                    </a:lnL>
+                    <a:lnR w="12700" cap="flat" cmpd="sng" algn="ctr">
+                      <a:noFill/>
+                      <a:prstDash val="solid"/>
+                      <a:round/>
+                      <a:headEnd type="none" w="med" len="med"/>
+                      <a:tailEnd type="none" w="med" len="med"/>
+                    </a:lnR>
+                    <a:lnT w="12700" cap="flat" cmpd="sng" algn="ctr">
+                      <a:noFill/>
+                      <a:prstDash val="solid"/>
+                      <a:round/>
+                      <a:headEnd type="none" w="med" len="med"/>
+                      <a:tailEnd type="none" w="med" len="med"/>
+                    </a:lnT>
+                    <a:lnB w="12700" cap="flat" cmpd="sng" algn="ctr">
+                      <a:noFill/>
+                      <a:prstDash val="solid"/>
+                      <a:round/>
+                      <a:headEnd type="none" w="med" len="med"/>
+                      <a:tailEnd type="none" w="med" len="med"/>
+                    </a:lnB>
+                    <a:solidFill>
+                      <a:schemeClr val="tx1"/>
+                    </a:solidFill>
+                  </a:tcPr>
+                </a:tc>
+                <a:tc>
+                  <a:txBody>
+                    <a:bodyPr/>
+                    <a:lstStyle/>
+                    <a:p>
+                      <a:pPr algn="l" fontAlgn="ctr">
+                        <a:buNone/>
+                      </a:pPr>
+                      <a:r>
+                        <a:rPr lang="en-IL" sz="1050" b="0" i="0">
+                          <a:solidFill>
+                            <a:schemeClr val="bg1"/>
+                          </a:solidFill>
+                          <a:effectLst/>
+                          <a:latin typeface="Segoe WPC"/>
+                        </a:rPr>
+                        <a:t>0.293025</a:t>
+                      </a:r>
+                    </a:p>
+                  </a:txBody>
+                  <a:tcPr marL="60960" marR="60960" marT="30480" marB="30480" anchor="ctr">
+                    <a:lnL w="12700" cap="flat" cmpd="sng" algn="ctr">
+                      <a:noFill/>
+                      <a:prstDash val="solid"/>
+                      <a:round/>
+                      <a:headEnd type="none" w="med" len="med"/>
+                      <a:tailEnd type="none" w="med" len="med"/>
+                    </a:lnL>
+                    <a:lnR w="12700" cap="flat" cmpd="sng" algn="ctr">
+                      <a:noFill/>
+                      <a:prstDash val="solid"/>
+                      <a:round/>
+                      <a:headEnd type="none" w="med" len="med"/>
+                      <a:tailEnd type="none" w="med" len="med"/>
+                    </a:lnR>
+                    <a:lnT w="12700" cap="flat" cmpd="sng" algn="ctr">
+                      <a:noFill/>
+                      <a:prstDash val="solid"/>
+                      <a:round/>
+                      <a:headEnd type="none" w="med" len="med"/>
+                      <a:tailEnd type="none" w="med" len="med"/>
+                    </a:lnT>
+                    <a:lnB w="12700" cap="flat" cmpd="sng" algn="ctr">
+                      <a:noFill/>
+                      <a:prstDash val="solid"/>
+                      <a:round/>
+                      <a:headEnd type="none" w="med" len="med"/>
+                      <a:tailEnd type="none" w="med" len="med"/>
+                    </a:lnB>
+                    <a:solidFill>
+                      <a:schemeClr val="tx1"/>
+                    </a:solidFill>
+                  </a:tcPr>
+                </a:tc>
+                <a:tc>
+                  <a:txBody>
+                    <a:bodyPr/>
+                    <a:lstStyle/>
+                    <a:p>
+                      <a:pPr algn="l" fontAlgn="ctr">
+                        <a:buNone/>
+                      </a:pPr>
+                      <a:r>
+                        <a:rPr lang="en-IL" sz="1050" b="0" i="0" dirty="0">
+                          <a:solidFill>
+                            <a:schemeClr val="bg1"/>
+                          </a:solidFill>
+                          <a:effectLst/>
+                          <a:latin typeface="Segoe WPC"/>
+                        </a:rPr>
+                        <a:t>true, better mayor, congratulations </a:t>
+                      </a:r>
+                    </a:p>
+                  </a:txBody>
+                  <a:tcPr marL="60960" marR="60960" marT="30480" marB="30480" anchor="ctr">
+                    <a:lnL w="12700" cap="flat" cmpd="sng" algn="ctr">
+                      <a:noFill/>
+                      <a:prstDash val="solid"/>
+                      <a:round/>
+                      <a:headEnd type="none" w="med" len="med"/>
+                      <a:tailEnd type="none" w="med" len="med"/>
+                    </a:lnL>
+                    <a:lnR w="12700" cap="flat" cmpd="sng" algn="ctr">
+                      <a:noFill/>
+                      <a:prstDash val="solid"/>
+                      <a:round/>
+                      <a:headEnd type="none" w="med" len="med"/>
+                      <a:tailEnd type="none" w="med" len="med"/>
+                    </a:lnR>
+                    <a:lnT w="12700" cap="flat" cmpd="sng" algn="ctr">
+                      <a:noFill/>
+                      <a:prstDash val="solid"/>
+                      <a:round/>
+                      <a:headEnd type="none" w="med" len="med"/>
+                      <a:tailEnd type="none" w="med" len="med"/>
+                    </a:lnT>
+                    <a:lnB w="12700" cap="flat" cmpd="sng" algn="ctr">
+                      <a:noFill/>
+                      <a:prstDash val="solid"/>
+                      <a:round/>
+                      <a:headEnd type="none" w="med" len="med"/>
+                      <a:tailEnd type="none" w="med" len="med"/>
+                    </a:lnB>
+                    <a:solidFill>
+                      <a:schemeClr val="tx1"/>
+                    </a:solidFill>
+                  </a:tcPr>
+                </a:tc>
+                <a:extLst>
+                  <a:ext uri="{0D108BD9-81ED-4DB2-BD59-A6C34878D82A}">
+                    <a16:rowId xmlns:a16="http://schemas.microsoft.com/office/drawing/2014/main" val="3111328741"/>
+                  </a:ext>
+                </a:extLst>
+              </a:tr>
+              <a:tr h="335259">
+                <a:tc>
+                  <a:txBody>
+                    <a:bodyPr/>
+                    <a:lstStyle/>
+                    <a:p>
+                      <a:pPr algn="l" fontAlgn="ctr">
+                        <a:buNone/>
+                      </a:pPr>
+                      <a:r>
+                        <a:rPr lang="en-IL" sz="1050" b="0" i="0" dirty="0">
+                          <a:solidFill>
+                            <a:schemeClr val="bg1"/>
+                          </a:solidFill>
+                          <a:effectLst/>
+                          <a:latin typeface="Segoe WPC"/>
+                        </a:rPr>
+                        <a:t>2018-03-18 14:49:00</a:t>
+                      </a:r>
+                    </a:p>
+                  </a:txBody>
+                  <a:tcPr marL="60960" marR="60960" marT="30480" marB="30480" anchor="ctr">
+                    <a:lnL w="12700" cap="flat" cmpd="sng" algn="ctr">
+                      <a:noFill/>
+                      <a:prstDash val="solid"/>
+                      <a:round/>
+                      <a:headEnd type="none" w="med" len="med"/>
+                      <a:tailEnd type="none" w="med" len="med"/>
+                    </a:lnL>
+                    <a:lnR w="12700" cap="flat" cmpd="sng" algn="ctr">
+                      <a:noFill/>
+                      <a:prstDash val="solid"/>
+                      <a:round/>
+                      <a:headEnd type="none" w="med" len="med"/>
+                      <a:tailEnd type="none" w="med" len="med"/>
+                    </a:lnR>
+                    <a:lnT w="12700" cap="flat" cmpd="sng" algn="ctr">
+                      <a:noFill/>
+                      <a:prstDash val="solid"/>
+                      <a:round/>
+                      <a:headEnd type="none" w="med" len="med"/>
+                      <a:tailEnd type="none" w="med" len="med"/>
+                    </a:lnT>
+                    <a:lnB w="12700" cap="flat" cmpd="sng" algn="ctr">
+                      <a:noFill/>
+                      <a:prstDash val="solid"/>
+                      <a:round/>
+                      <a:headEnd type="none" w="med" len="med"/>
+                      <a:tailEnd type="none" w="med" len="med"/>
+                    </a:lnB>
+                    <a:solidFill>
+                      <a:schemeClr val="tx1"/>
+                    </a:solidFill>
+                  </a:tcPr>
+                </a:tc>
+                <a:tc>
+                  <a:txBody>
+                    <a:bodyPr/>
+                    <a:lstStyle/>
+                    <a:p>
+                      <a:pPr algn="l" fontAlgn="ctr">
+                        <a:buNone/>
+                      </a:pPr>
+                      <a:r>
+                        <a:rPr lang="en-IL" sz="1050" b="0" i="0" dirty="0">
+                          <a:solidFill>
+                            <a:schemeClr val="bg1"/>
+                          </a:solidFill>
+                          <a:effectLst/>
+                          <a:latin typeface="Segoe WPC"/>
+                        </a:rPr>
+                        <a:t>0.268000</a:t>
+                      </a:r>
+                    </a:p>
+                  </a:txBody>
+                  <a:tcPr marL="60960" marR="60960" marT="30480" marB="30480" anchor="ctr">
+                    <a:lnL w="12700" cap="flat" cmpd="sng" algn="ctr">
+                      <a:noFill/>
+                      <a:prstDash val="solid"/>
+                      <a:round/>
+                      <a:headEnd type="none" w="med" len="med"/>
+                      <a:tailEnd type="none" w="med" len="med"/>
+                    </a:lnL>
+                    <a:lnR w="12700" cap="flat" cmpd="sng" algn="ctr">
+                      <a:noFill/>
+                      <a:prstDash val="solid"/>
+                      <a:round/>
+                      <a:headEnd type="none" w="med" len="med"/>
+                      <a:tailEnd type="none" w="med" len="med"/>
+                    </a:lnR>
+                    <a:lnT w="12700" cap="flat" cmpd="sng" algn="ctr">
+                      <a:noFill/>
+                      <a:prstDash val="solid"/>
+                      <a:round/>
+                      <a:headEnd type="none" w="med" len="med"/>
+                      <a:tailEnd type="none" w="med" len="med"/>
+                    </a:lnT>
+                    <a:lnB w="12700" cap="flat" cmpd="sng" algn="ctr">
+                      <a:noFill/>
+                      <a:prstDash val="solid"/>
+                      <a:round/>
+                      <a:headEnd type="none" w="med" len="med"/>
+                      <a:tailEnd type="none" w="med" len="med"/>
+                    </a:lnB>
+                    <a:solidFill>
+                      <a:schemeClr val="tx1"/>
+                    </a:solidFill>
+                  </a:tcPr>
+                </a:tc>
+                <a:tc>
+                  <a:txBody>
+                    <a:bodyPr/>
+                    <a:lstStyle/>
+                    <a:p>
+                      <a:pPr algn="l" fontAlgn="ctr">
+                        <a:buNone/>
+                      </a:pPr>
+                      <a:r>
+                        <a:rPr lang="en-IL" sz="1050" b="0" i="0" dirty="0">
+                          <a:solidFill>
+                            <a:schemeClr val="bg1"/>
+                          </a:solidFill>
+                          <a:effectLst/>
+                          <a:latin typeface="Segoe WPC"/>
+                        </a:rPr>
+                        <a:t>true, better mayor, congratulations </a:t>
+                      </a:r>
+                    </a:p>
+                  </a:txBody>
+                  <a:tcPr marL="60960" marR="60960" marT="30480" marB="30480" anchor="ctr">
+                    <a:lnL w="12700" cap="flat" cmpd="sng" algn="ctr">
+                      <a:noFill/>
+                      <a:prstDash val="solid"/>
+                      <a:round/>
+                      <a:headEnd type="none" w="med" len="med"/>
+                      <a:tailEnd type="none" w="med" len="med"/>
+                    </a:lnL>
+                    <a:lnR w="12700" cap="flat" cmpd="sng" algn="ctr">
+                      <a:noFill/>
+                      <a:prstDash val="solid"/>
+                      <a:round/>
+                      <a:headEnd type="none" w="med" len="med"/>
+                      <a:tailEnd type="none" w="med" len="med"/>
+                    </a:lnR>
+                    <a:lnT w="12700" cap="flat" cmpd="sng" algn="ctr">
+                      <a:noFill/>
+                      <a:prstDash val="solid"/>
+                      <a:round/>
+                      <a:headEnd type="none" w="med" len="med"/>
+                      <a:tailEnd type="none" w="med" len="med"/>
+                    </a:lnT>
+                    <a:lnB w="12700" cap="flat" cmpd="sng" algn="ctr">
+                      <a:noFill/>
+                      <a:prstDash val="solid"/>
+                      <a:round/>
+                      <a:headEnd type="none" w="med" len="med"/>
+                      <a:tailEnd type="none" w="med" len="med"/>
+                    </a:lnB>
+                    <a:solidFill>
+                      <a:schemeClr val="tx1"/>
+                    </a:solidFill>
+                  </a:tcPr>
+                </a:tc>
+                <a:extLst>
+                  <a:ext uri="{0D108BD9-81ED-4DB2-BD59-A6C34878D82A}">
+                    <a16:rowId xmlns:a16="http://schemas.microsoft.com/office/drawing/2014/main" val="1032634735"/>
+                  </a:ext>
+                </a:extLst>
+              </a:tr>
+            </a:tbl>
+          </a:graphicData>
+        </a:graphic>
+      </p:graphicFrame>
       <p:sp>
         <p:nvSpPr>
-          <p:cNvPr id="41" name="SharedPosts"/>
-          <p:cNvSpPr/>
+          <p:cNvPr id="13" name="TextBox 12">
+            <a:extLst>
+              <a:ext uri="{FF2B5EF4-FFF2-40B4-BE49-F238E27FC236}">
+                <a16:creationId xmlns:a16="http://schemas.microsoft.com/office/drawing/2014/main" id="{5C715B49-1A2B-E123-1F7E-C12DE5DDE56B}"/>
+              </a:ext>
+            </a:extLst>
+          </p:cNvPr>
+          <p:cNvSpPr txBox="1"/>
           <p:nvPr/>
         </p:nvSpPr>
         <p:spPr>
           <a:xfrm>
-            <a:off x="1463040" y="4187952"/>
-            <a:ext cx="9921240" cy="1847088"/>
-          </a:xfrm>
-          <a:prstGeom prst="roundRect">
-            <a:avLst/>
-          </a:prstGeom>
-          <a:solidFill>
-            <a:srgbClr val="F2F2F2"/>
-          </a:solidFill>
-          <a:ln w="9525">
-            <a:solidFill>
-              <a:srgbClr val="BFBFBF"/>
-            </a:solidFill>
-          </a:ln>
-        </p:spPr>
-        <p:txBody>
-          <a:bodyPr wrap="square" lIns="137160" tIns="91440" rIns="137160" bIns="91440">
-            <a:normAutofit fontScale="92500" lnSpcReduction="10000"/>
-          </a:bodyPr>
-          <a:lstStyle/>
-          <a:p>
-            <a:r>
-              <a:rPr lang="en-IL" b="1" dirty="0"/>
-              <a:t>Both accounts published the exact same text, word for word:</a:t>
-            </a:r>
-          </a:p>
-          <a:p>
-            <a:r>
-              <a:rPr lang="en-IL" sz="1600" b="1" dirty="0"/>
-              <a:t>14.03.2019, 71cc5715…:  </a:t>
-            </a:r>
-            <a:r>
-              <a:rPr lang="en-IL" sz="1600" i="1" dirty="0"/>
-              <a:t>“Regulation shall enter force twentieth day following publication official journal european union.”</a:t>
-            </a:r>
-          </a:p>
-          <a:p>
-            <a:r>
-              <a:rPr lang="en-IL" sz="1600" b="1" dirty="0"/>
-              <a:t>02.05.2019, 712125a6…:  </a:t>
-            </a:r>
-            <a:r>
-              <a:rPr lang="en-IL" sz="1600" i="1" dirty="0"/>
-              <a:t>“Regulation shall enter force twentieth day following publication official journal european union.”</a:t>
-            </a:r>
-          </a:p>
-          <a:p>
-            <a:r>
-              <a:rPr lang="en-IL" sz="1600" dirty="0"/>
-              <a:t>Both accounts mix pro-government praise with the same off-topic EU legal boilerplate.</a:t>
-            </a:r>
-          </a:p>
-          <a:p>
-            <a:r>
-              <a:rPr lang="en-IL" sz="1100" i="1" dirty="0">
-                <a:solidFill>
-                  <a:srgbClr val="7F7F7F"/>
-                </a:solidFill>
-              </a:rPr>
-              <a:t>Posts shown as stored in the dataset (translated and preprocessed).</a:t>
-            </a:r>
-          </a:p>
-        </p:txBody>
-      </p:sp>
-      <p:sp>
-        <p:nvSpPr>
-          <p:cNvPr id="42" name="Foot"/>
-          <p:cNvSpPr/>
-          <p:nvPr/>
-        </p:nvSpPr>
-        <p:spPr>
-          <a:xfrm>
-            <a:off x="1554480" y="6199632"/>
-            <a:ext cx="7680960" cy="411480"/>
+            <a:off x="1800225" y="6276689"/>
+            <a:ext cx="8000999" cy="646331"/>
           </a:xfrm>
           <a:prstGeom prst="rect">
             <a:avLst/>
@@ -13985,13 +16286,42 @@
           <a:noFill/>
         </p:spPr>
         <p:txBody>
-          <a:bodyPr lIns="0" tIns="0"/>
+          <a:bodyPr wrap="square" rtlCol="0">
+            <a:spAutoFit/>
+          </a:bodyPr>
           <a:lstStyle/>
           <a:p>
             <a:r>
-              <a:rPr lang="en-IL" sz="1350" b="1" dirty="0"/>
-              <a:t>Just 2 of the 107 accounts in this k-core. This is the coordination the co-action graph captures.</a:t>
-            </a:r>
+              <a:rPr lang="en-US" dirty="0"/>
+              <a:t>Top five posts by </a:t>
+            </a:r>
+            <a:r>
+              <a:rPr lang="en-US" dirty="0" err="1"/>
+              <a:t>post_tdidf</a:t>
+            </a:r>
+            <a:r>
+              <a:rPr lang="en-US" dirty="0"/>
+              <a:t> score.</a:t>
+            </a:r>
+          </a:p>
+          <a:p>
+            <a:r>
+              <a:rPr lang="en-US" dirty="0" err="1"/>
+              <a:t>post_tdidf</a:t>
+            </a:r>
+            <a:r>
+              <a:rPr lang="en-US" dirty="0"/>
+              <a:t>: sum of the </a:t>
+            </a:r>
+            <a:r>
+              <a:rPr lang="en-US" dirty="0" err="1"/>
+              <a:t>tf-idf</a:t>
+            </a:r>
+            <a:r>
+              <a:rPr lang="en-US" dirty="0"/>
+              <a:t> score of all the entities in the post.</a:t>
+            </a:r>
+            <a:endParaRPr lang="en-IL" dirty="0"/>
           </a:p>
         </p:txBody>
       </p:sp>
@@ -14093,89 +16423,88 @@
               <a:buNone/>
             </a:pPr>
             <a:r>
-              <a:rPr lang="en-IL" sz="2600" dirty="0"/>
+              <a:rPr lang="en-IL" sz="2800" dirty="0"/>
               <a:t>An LLM</a:t>
             </a:r>
             <a:r>
-              <a:rPr lang="en-GB" sz="2600" dirty="0"/>
-              <a:t> </a:t>
-            </a:r>
-            <a:r>
-              <a:rPr lang="en-GB" sz="1800" dirty="0"/>
-              <a:t>(</a:t>
-            </a:r>
-            <a:r>
-              <a:rPr lang="en-IL" sz="1800" dirty="0"/>
+              <a:rPr lang="en-GB" sz="2800" dirty="0"/>
+              <a:t> (</a:t>
+            </a:r>
+            <a:r>
+              <a:rPr lang="en-IL" sz="2800" dirty="0"/>
               <a:t>OpenAI ChatGPT web interface</a:t>
             </a:r>
             <a:r>
-              <a:rPr lang="en-GB" sz="1800" dirty="0"/>
+              <a:rPr lang="en-GB" sz="2800" dirty="0"/>
               <a:t>)</a:t>
             </a:r>
             <a:r>
-              <a:rPr lang="en-IL" sz="1800" dirty="0"/>
-              <a:t> </a:t>
-            </a:r>
-            <a:r>
-              <a:rPr lang="en-IL" sz="2600" dirty="0"/>
-              <a:t>was provided with the top 10 posts from each account, ranked by TF-IDF score. The </a:t>
-            </a:r>
-            <a:r>
-              <a:rPr lang="en-GB" sz="2600" dirty="0"/>
+              <a:rPr lang="en-IL" sz="2800" dirty="0"/>
+              <a:t> was provided with the top </a:t>
+            </a:r>
+            <a:r>
+              <a:rPr lang="en-US" sz="2800" dirty="0"/>
+              <a:t>5</a:t>
+            </a:r>
+            <a:r>
+              <a:rPr lang="en-IL" sz="2800" dirty="0"/>
+              <a:t> posts from each account, ranked by TF-IDF score. The </a:t>
+            </a:r>
+            <a:r>
+              <a:rPr lang="en-GB" sz="2800" dirty="0"/>
               <a:t>model</a:t>
             </a:r>
             <a:r>
-              <a:rPr lang="en-IL" sz="2600" dirty="0"/>
+              <a:rPr lang="en-IL" sz="2800" dirty="0"/>
               <a:t> identified the following patterns:</a:t>
             </a:r>
-            <a:endParaRPr lang="en-GB" sz="2600" dirty="0"/>
+            <a:endParaRPr lang="en-US" sz="2800" dirty="0"/>
+          </a:p>
+          <a:p>
+            <a:pPr marL="0" indent="0">
+              <a:buNone/>
+            </a:pPr>
+            <a:endParaRPr lang="en-GB" sz="2800" dirty="0"/>
           </a:p>
           <a:p>
             <a:pPr marL="514350" indent="-514350">
               <a:buAutoNum type="arabicPeriod"/>
             </a:pPr>
             <a:r>
-              <a:rPr lang="en-IL" sz="2600" dirty="0"/>
-              <a:t>Promotion of the Ecuadorian president and government policies.</a:t>
-            </a:r>
-            <a:endParaRPr lang="en-GB" sz="2600" dirty="0"/>
+              <a:rPr lang="en-IL" sz="2800" dirty="0"/>
+              <a:t>Repeated posting of identical political messages, rather than varied discussion.</a:t>
+            </a:r>
+            <a:endParaRPr lang="en-US" sz="2800" dirty="0"/>
           </a:p>
           <a:p>
             <a:pPr marL="514350" indent="-514350">
               <a:buAutoNum type="arabicPeriod"/>
             </a:pPr>
             <a:r>
-              <a:rPr lang="en-IL" sz="2600" dirty="0"/>
-              <a:t>Emphasis on social programs, security, democracy, and government achievements.</a:t>
-            </a:r>
-            <a:endParaRPr lang="en-GB" sz="2600" dirty="0"/>
+              <a:rPr lang="en-IL" sz="2800" dirty="0"/>
+              <a:t>Very little textual diversity</a:t>
+            </a:r>
+            <a:r>
+              <a:rPr lang="en-US" sz="2800" dirty="0"/>
+              <a:t>.</a:t>
+            </a:r>
           </a:p>
           <a:p>
             <a:pPr marL="514350" indent="-514350">
               <a:buAutoNum type="arabicPeriod"/>
             </a:pPr>
             <a:r>
-              <a:rPr lang="en-IL" sz="2600" dirty="0"/>
-              <a:t>Reuse of similar supportive language across accounts.</a:t>
-            </a:r>
-            <a:endParaRPr lang="en-GB" sz="2600" dirty="0"/>
+              <a:rPr lang="en-IL" sz="2800" dirty="0"/>
+              <a:t>Mostly mayor-related content</a:t>
+            </a:r>
+            <a:endParaRPr lang="en-US" sz="2800" dirty="0"/>
           </a:p>
           <a:p>
             <a:pPr marL="514350" indent="-514350">
               <a:buAutoNum type="arabicPeriod"/>
             </a:pPr>
             <a:r>
-              <a:rPr lang="en-IL" sz="2600" dirty="0"/>
-              <a:t>Unusually repetitive references to EU legal and institutional content.</a:t>
-            </a:r>
-            <a:endParaRPr lang="en-GB" sz="2600" dirty="0"/>
-          </a:p>
-          <a:p>
-            <a:pPr marL="514350" indent="-514350">
-              <a:buAutoNum type="arabicPeriod"/>
-            </a:pPr>
-            <a:r>
-              <a:rPr lang="en-IL" sz="2600" b="1" dirty="0"/>
+              <a:rPr lang="en-IL" sz="2800" b="1" dirty="0"/>
               <a:t>Shared narratives that may indicate coordinated or automated activity.</a:t>
             </a:r>
           </a:p>
@@ -14907,6 +17236,197 @@
 </file>
 
 <file path=ppt/slides/slide24.xml><?xml version="1.0" encoding="utf-8"?>
+<p:sld xmlns:a="http://schemas.openxmlformats.org/drawingml/2006/main" xmlns:r="http://schemas.openxmlformats.org/officeDocument/2006/relationships" xmlns:p="http://schemas.openxmlformats.org/presentationml/2006/main" show="0">
+  <p:cSld>
+    <p:spTree>
+      <p:nvGrpSpPr>
+        <p:cNvPr id="1" name="">
+          <a:extLst>
+            <a:ext uri="{FF2B5EF4-FFF2-40B4-BE49-F238E27FC236}">
+              <a16:creationId xmlns:a16="http://schemas.microsoft.com/office/drawing/2014/main" id="{D7AE9B09-6B22-8F18-2C83-5F01E14DDC49}"/>
+            </a:ext>
+          </a:extLst>
+        </p:cNvPr>
+        <p:cNvGrpSpPr/>
+        <p:nvPr/>
+      </p:nvGrpSpPr>
+      <p:grpSpPr>
+        <a:xfrm>
+          <a:off x="0" y="0"/>
+          <a:ext cx="0" cy="0"/>
+          <a:chOff x="0" y="0"/>
+          <a:chExt cx="0" cy="0"/>
+        </a:xfrm>
+      </p:grpSpPr>
+      <p:sp>
+        <p:nvSpPr>
+          <p:cNvPr id="2" name="Title 1">
+            <a:extLst>
+              <a:ext uri="{FF2B5EF4-FFF2-40B4-BE49-F238E27FC236}">
+                <a16:creationId xmlns:a16="http://schemas.microsoft.com/office/drawing/2014/main" id="{957A2716-3774-3DEC-5CA3-DAFEB7ECBEE4}"/>
+              </a:ext>
+            </a:extLst>
+          </p:cNvPr>
+          <p:cNvSpPr>
+            <a:spLocks noGrp="1"/>
+          </p:cNvSpPr>
+          <p:nvPr>
+            <p:ph type="title"/>
+          </p:nvPr>
+        </p:nvSpPr>
+        <p:spPr/>
+        <p:txBody>
+          <a:bodyPr anchor="ctr">
+            <a:normAutofit/>
+          </a:bodyPr>
+          <a:lstStyle/>
+          <a:p>
+            <a:r>
+              <a:rPr lang="en-US" dirty="0"/>
+              <a:t>Correlation Heatmap</a:t>
+            </a:r>
+            <a:endParaRPr lang="en-IL" dirty="0"/>
+          </a:p>
+        </p:txBody>
+      </p:sp>
+      <p:sp>
+        <p:nvSpPr>
+          <p:cNvPr id="4" name="Slide Number Placeholder 3">
+            <a:extLst>
+              <a:ext uri="{FF2B5EF4-FFF2-40B4-BE49-F238E27FC236}">
+                <a16:creationId xmlns:a16="http://schemas.microsoft.com/office/drawing/2014/main" id="{D18168F4-1251-2C67-E550-4502FBEEEE53}"/>
+              </a:ext>
+            </a:extLst>
+          </p:cNvPr>
+          <p:cNvSpPr>
+            <a:spLocks noGrp="1"/>
+          </p:cNvSpPr>
+          <p:nvPr>
+            <p:ph type="sldNum" sz="quarter" idx="12"/>
+          </p:nvPr>
+        </p:nvSpPr>
+        <p:spPr>
+          <a:xfrm>
+            <a:off x="11728704" y="6464649"/>
+            <a:ext cx="452233" cy="365125"/>
+          </a:xfrm>
+        </p:spPr>
+        <p:txBody>
+          <a:bodyPr anchor="ctr">
+            <a:normAutofit/>
+          </a:bodyPr>
+          <a:lstStyle/>
+          <a:p>
+            <a:pPr>
+              <a:spcAft>
+                <a:spcPts val="600"/>
+              </a:spcAft>
+            </a:pPr>
+            <a:fld id="{E6AB8EDD-9EF2-4633-A1C2-4D908C1019B4}" type="slidenum">
+              <a:rPr lang="he-IL" smtClean="0"/>
+              <a:pPr>
+                <a:spcAft>
+                  <a:spcPts val="600"/>
+                </a:spcAft>
+              </a:pPr>
+              <a:t>24</a:t>
+            </a:fld>
+            <a:endParaRPr lang="he-IL"/>
+          </a:p>
+        </p:txBody>
+      </p:sp>
+      <p:sp>
+        <p:nvSpPr>
+          <p:cNvPr id="8" name="TextBox 7">
+            <a:extLst>
+              <a:ext uri="{FF2B5EF4-FFF2-40B4-BE49-F238E27FC236}">
+                <a16:creationId xmlns:a16="http://schemas.microsoft.com/office/drawing/2014/main" id="{4CC0BD5E-7223-B9A6-106D-970C2443C90A}"/>
+              </a:ext>
+            </a:extLst>
+          </p:cNvPr>
+          <p:cNvSpPr txBox="1"/>
+          <p:nvPr/>
+        </p:nvSpPr>
+        <p:spPr>
+          <a:xfrm>
+            <a:off x="9510668" y="1727200"/>
+            <a:ext cx="2681332" cy="369332"/>
+          </a:xfrm>
+          <a:prstGeom prst="rect">
+            <a:avLst/>
+          </a:prstGeom>
+          <a:noFill/>
+        </p:spPr>
+        <p:txBody>
+          <a:bodyPr wrap="square" rtlCol="0">
+            <a:spAutoFit/>
+          </a:bodyPr>
+          <a:lstStyle/>
+          <a:p>
+            <a:r>
+              <a:rPr lang="en-US" dirty="0">
+                <a:solidFill>
+                  <a:schemeClr val="bg1">
+                    <a:lumMod val="50000"/>
+                  </a:schemeClr>
+                </a:solidFill>
+              </a:rPr>
+              <a:t>On Ecuador Campaign</a:t>
+            </a:r>
+            <a:endParaRPr lang="en-IL" dirty="0">
+              <a:solidFill>
+                <a:schemeClr val="bg1">
+                  <a:lumMod val="50000"/>
+                </a:schemeClr>
+              </a:solidFill>
+            </a:endParaRPr>
+          </a:p>
+        </p:txBody>
+      </p:sp>
+      <p:pic>
+        <p:nvPicPr>
+          <p:cNvPr id="9" name="Picture 8">
+            <a:extLst>
+              <a:ext uri="{FF2B5EF4-FFF2-40B4-BE49-F238E27FC236}">
+                <a16:creationId xmlns:a16="http://schemas.microsoft.com/office/drawing/2014/main" id="{57D0D072-E40A-9DBD-89CC-6D6446849FB4}"/>
+              </a:ext>
+            </a:extLst>
+          </p:cNvPr>
+          <p:cNvPicPr>
+            <a:picLocks noChangeAspect="1"/>
+          </p:cNvPicPr>
+          <p:nvPr/>
+        </p:nvPicPr>
+        <p:blipFill>
+          <a:blip r:embed="rId2"/>
+          <a:stretch>
+            <a:fillRect/>
+          </a:stretch>
+        </p:blipFill>
+        <p:spPr>
+          <a:xfrm>
+            <a:off x="3072268" y="1301088"/>
+            <a:ext cx="5442423" cy="5528686"/>
+          </a:xfrm>
+          <a:prstGeom prst="rect">
+            <a:avLst/>
+          </a:prstGeom>
+        </p:spPr>
+      </p:pic>
+    </p:spTree>
+    <p:extLst>
+      <p:ext uri="{BB962C8B-B14F-4D97-AF65-F5344CB8AC3E}">
+        <p14:creationId xmlns:p14="http://schemas.microsoft.com/office/powerpoint/2010/main" val="990613334"/>
+      </p:ext>
+    </p:extLst>
+  </p:cSld>
+  <p:clrMapOvr>
+    <a:masterClrMapping/>
+  </p:clrMapOvr>
+</p:sld>
+</file>
+
+<file path=ppt/slides/slide25.xml><?xml version="1.0" encoding="utf-8"?>
 <p:sld xmlns:a="http://schemas.openxmlformats.org/drawingml/2006/main" xmlns:r="http://schemas.openxmlformats.org/officeDocument/2006/relationships" xmlns:p="http://schemas.openxmlformats.org/presentationml/2006/main">
   <p:cSld>
     <p:spTree>
@@ -15045,7 +17565,7 @@
           <a:p>
             <a:fld id="{E6AB8EDD-9EF2-4633-A1C2-4D908C1019B4}" type="slidenum">
               <a:rPr lang="he-IL" smtClean="0"/>
-              <a:t>24</a:t>
+              <a:t>25</a:t>
             </a:fld>
             <a:endParaRPr lang="he-IL"/>
           </a:p>
@@ -15184,7 +17704,7 @@
 </p:sld>
 </file>
 
-<file path=ppt/slides/slide25.xml><?xml version="1.0" encoding="utf-8"?>
+<file path=ppt/slides/slide26.xml><?xml version="1.0" encoding="utf-8"?>
 <p:sld xmlns:a="http://schemas.openxmlformats.org/drawingml/2006/main" xmlns:r="http://schemas.openxmlformats.org/officeDocument/2006/relationships" xmlns:p="http://schemas.openxmlformats.org/presentationml/2006/main">
   <p:cSld>
     <p:spTree>
@@ -15311,7 +17831,7 @@
           <a:p>
             <a:fld id="{E6AB8EDD-9EF2-4633-A1C2-4D908C1019B4}" type="slidenum">
               <a:rPr lang="he-IL" smtClean="0"/>
-              <a:t>25</a:t>
+              <a:t>26</a:t>
             </a:fld>
             <a:endParaRPr lang="he-IL"/>
           </a:p>
@@ -15321,450 +17841,6 @@
     <p:extLst>
       <p:ext uri="{BB962C8B-B14F-4D97-AF65-F5344CB8AC3E}">
         <p14:creationId xmlns:p14="http://schemas.microsoft.com/office/powerpoint/2010/main" val="311971578"/>
-      </p:ext>
-    </p:extLst>
-  </p:cSld>
-  <p:clrMapOvr>
-    <a:masterClrMapping/>
-  </p:clrMapOvr>
-</p:sld>
-</file>
-
-<file path=ppt/slides/slide26.xml><?xml version="1.0" encoding="utf-8"?>
-<p:sld xmlns:a="http://schemas.openxmlformats.org/drawingml/2006/main" xmlns:r="http://schemas.openxmlformats.org/officeDocument/2006/relationships" xmlns:p="http://schemas.openxmlformats.org/presentationml/2006/main" show="0">
-  <p:cSld>
-    <p:spTree>
-      <p:nvGrpSpPr>
-        <p:cNvPr id="1" name="">
-          <a:extLst>
-            <a:ext uri="{FF2B5EF4-FFF2-40B4-BE49-F238E27FC236}">
-              <a16:creationId xmlns:a16="http://schemas.microsoft.com/office/drawing/2014/main" id="{4F1D631C-0474-31A2-8F4A-253AE6BB3179}"/>
-            </a:ext>
-          </a:extLst>
-        </p:cNvPr>
-        <p:cNvGrpSpPr/>
-        <p:nvPr/>
-      </p:nvGrpSpPr>
-      <p:grpSpPr>
-        <a:xfrm>
-          <a:off x="0" y="0"/>
-          <a:ext cx="0" cy="0"/>
-          <a:chOff x="0" y="0"/>
-          <a:chExt cx="0" cy="0"/>
-        </a:xfrm>
-      </p:grpSpPr>
-      <p:sp>
-        <p:nvSpPr>
-          <p:cNvPr id="2" name="Title 1">
-            <a:extLst>
-              <a:ext uri="{FF2B5EF4-FFF2-40B4-BE49-F238E27FC236}">
-                <a16:creationId xmlns:a16="http://schemas.microsoft.com/office/drawing/2014/main" id="{A3F3302A-DA36-40AE-FEB5-58196BE76355}"/>
-              </a:ext>
-            </a:extLst>
-          </p:cNvPr>
-          <p:cNvSpPr>
-            <a:spLocks noGrp="1"/>
-          </p:cNvSpPr>
-          <p:nvPr>
-            <p:ph type="title"/>
-          </p:nvPr>
-        </p:nvSpPr>
-        <p:spPr>
-          <a:xfrm>
-            <a:off x="3427462" y="-55282"/>
-            <a:ext cx="8753475" cy="1325563"/>
-          </a:xfrm>
-        </p:spPr>
-        <p:txBody>
-          <a:bodyPr anchor="ctr">
-            <a:normAutofit/>
-          </a:bodyPr>
-          <a:lstStyle/>
-          <a:p>
-            <a:r>
-              <a:rPr lang="en-GB" dirty="0"/>
-              <a:t>K-Core Example - Top Posts</a:t>
-            </a:r>
-            <a:endParaRPr lang="en-IL" dirty="0"/>
-          </a:p>
-        </p:txBody>
-      </p:sp>
-      <p:sp>
-        <p:nvSpPr>
-          <p:cNvPr id="4" name="Slide Number Placeholder 3">
-            <a:extLst>
-              <a:ext uri="{FF2B5EF4-FFF2-40B4-BE49-F238E27FC236}">
-                <a16:creationId xmlns:a16="http://schemas.microsoft.com/office/drawing/2014/main" id="{9DD7C468-10F2-3E81-3E4F-33E979828858}"/>
-              </a:ext>
-            </a:extLst>
-          </p:cNvPr>
-          <p:cNvSpPr>
-            <a:spLocks noGrp="1"/>
-          </p:cNvSpPr>
-          <p:nvPr>
-            <p:ph type="sldNum" sz="quarter" idx="12"/>
-          </p:nvPr>
-        </p:nvSpPr>
-        <p:spPr>
-          <a:xfrm>
-            <a:off x="11728704" y="6464649"/>
-            <a:ext cx="452233" cy="365125"/>
-          </a:xfrm>
-        </p:spPr>
-        <p:txBody>
-          <a:bodyPr anchor="ctr">
-            <a:normAutofit/>
-          </a:bodyPr>
-          <a:lstStyle/>
-          <a:p>
-            <a:pPr>
-              <a:spcAft>
-                <a:spcPts val="600"/>
-              </a:spcAft>
-            </a:pPr>
-            <a:fld id="{E6AB8EDD-9EF2-4633-A1C2-4D908C1019B4}" type="slidenum">
-              <a:rPr lang="he-IL" smtClean="0"/>
-              <a:pPr>
-                <a:spcAft>
-                  <a:spcPts val="600"/>
-                </a:spcAft>
-              </a:pPr>
-              <a:t>26</a:t>
-            </a:fld>
-            <a:endParaRPr lang="he-IL"/>
-          </a:p>
-        </p:txBody>
-      </p:sp>
-      <p:pic>
-        <p:nvPicPr>
-          <p:cNvPr id="5" name="Picture 4">
-            <a:extLst>
-              <a:ext uri="{FF2B5EF4-FFF2-40B4-BE49-F238E27FC236}">
-                <a16:creationId xmlns:a16="http://schemas.microsoft.com/office/drawing/2014/main" id="{74F5A9A0-E4E7-9D8E-1B78-578AEA1FAECD}"/>
-              </a:ext>
-            </a:extLst>
-          </p:cNvPr>
-          <p:cNvPicPr>
-            <a:picLocks noChangeAspect="1"/>
-          </p:cNvPicPr>
-          <p:nvPr/>
-        </p:nvPicPr>
-        <p:blipFill>
-          <a:blip r:embed="rId2"/>
-          <a:stretch>
-            <a:fillRect/>
-          </a:stretch>
-        </p:blipFill>
-        <p:spPr>
-          <a:xfrm>
-            <a:off x="1930567" y="931251"/>
-            <a:ext cx="8941869" cy="5304983"/>
-          </a:xfrm>
-          <a:prstGeom prst="rect">
-            <a:avLst/>
-          </a:prstGeom>
-        </p:spPr>
-      </p:pic>
-    </p:spTree>
-    <p:extLst>
-      <p:ext uri="{BB962C8B-B14F-4D97-AF65-F5344CB8AC3E}">
-        <p14:creationId xmlns:p14="http://schemas.microsoft.com/office/powerpoint/2010/main" val="1919473928"/>
-      </p:ext>
-    </p:extLst>
-  </p:cSld>
-  <p:clrMapOvr>
-    <a:masterClrMapping/>
-  </p:clrMapOvr>
-</p:sld>
-</file>
-
-<file path=ppt/slides/slide27.xml><?xml version="1.0" encoding="utf-8"?>
-<p:sld xmlns:a="http://schemas.openxmlformats.org/drawingml/2006/main" xmlns:r="http://schemas.openxmlformats.org/officeDocument/2006/relationships" xmlns:p="http://schemas.openxmlformats.org/presentationml/2006/main" show="0">
-  <p:cSld>
-    <p:spTree>
-      <p:nvGrpSpPr>
-        <p:cNvPr id="1" name="">
-          <a:extLst>
-            <a:ext uri="{FF2B5EF4-FFF2-40B4-BE49-F238E27FC236}">
-              <a16:creationId xmlns:a16="http://schemas.microsoft.com/office/drawing/2014/main" id="{E4F1B31F-78F0-7858-AE46-3A6AB43B795D}"/>
-            </a:ext>
-          </a:extLst>
-        </p:cNvPr>
-        <p:cNvGrpSpPr/>
-        <p:nvPr/>
-      </p:nvGrpSpPr>
-      <p:grpSpPr>
-        <a:xfrm>
-          <a:off x="0" y="0"/>
-          <a:ext cx="0" cy="0"/>
-          <a:chOff x="0" y="0"/>
-          <a:chExt cx="0" cy="0"/>
-        </a:xfrm>
-      </p:grpSpPr>
-      <p:sp>
-        <p:nvSpPr>
-          <p:cNvPr id="2" name="Title 1">
-            <a:extLst>
-              <a:ext uri="{FF2B5EF4-FFF2-40B4-BE49-F238E27FC236}">
-                <a16:creationId xmlns:a16="http://schemas.microsoft.com/office/drawing/2014/main" id="{1D1DE87F-7930-4BE1-329A-4F3A5152B216}"/>
-              </a:ext>
-            </a:extLst>
-          </p:cNvPr>
-          <p:cNvSpPr>
-            <a:spLocks noGrp="1"/>
-          </p:cNvSpPr>
-          <p:nvPr>
-            <p:ph type="title"/>
-          </p:nvPr>
-        </p:nvSpPr>
-        <p:spPr>
-          <a:xfrm>
-            <a:off x="3427462" y="-55282"/>
-            <a:ext cx="8753475" cy="1325563"/>
-          </a:xfrm>
-        </p:spPr>
-        <p:txBody>
-          <a:bodyPr anchor="ctr">
-            <a:normAutofit/>
-          </a:bodyPr>
-          <a:lstStyle/>
-          <a:p>
-            <a:r>
-              <a:rPr lang="en-GB" dirty="0"/>
-              <a:t>K-Core Example - Top Posts</a:t>
-            </a:r>
-            <a:endParaRPr lang="en-IL" dirty="0"/>
-          </a:p>
-        </p:txBody>
-      </p:sp>
-      <p:sp>
-        <p:nvSpPr>
-          <p:cNvPr id="4" name="Slide Number Placeholder 3">
-            <a:extLst>
-              <a:ext uri="{FF2B5EF4-FFF2-40B4-BE49-F238E27FC236}">
-                <a16:creationId xmlns:a16="http://schemas.microsoft.com/office/drawing/2014/main" id="{629F2D2A-63D8-B77A-FF2E-BBC8A572AA2A}"/>
-              </a:ext>
-            </a:extLst>
-          </p:cNvPr>
-          <p:cNvSpPr>
-            <a:spLocks noGrp="1"/>
-          </p:cNvSpPr>
-          <p:nvPr>
-            <p:ph type="sldNum" sz="quarter" idx="12"/>
-          </p:nvPr>
-        </p:nvSpPr>
-        <p:spPr>
-          <a:xfrm>
-            <a:off x="11728704" y="6464649"/>
-            <a:ext cx="452233" cy="365125"/>
-          </a:xfrm>
-        </p:spPr>
-        <p:txBody>
-          <a:bodyPr anchor="ctr">
-            <a:normAutofit/>
-          </a:bodyPr>
-          <a:lstStyle/>
-          <a:p>
-            <a:pPr>
-              <a:spcAft>
-                <a:spcPts val="600"/>
-              </a:spcAft>
-            </a:pPr>
-            <a:fld id="{E6AB8EDD-9EF2-4633-A1C2-4D908C1019B4}" type="slidenum">
-              <a:rPr lang="he-IL" smtClean="0"/>
-              <a:pPr>
-                <a:spcAft>
-                  <a:spcPts val="600"/>
-                </a:spcAft>
-              </a:pPr>
-              <a:t>27</a:t>
-            </a:fld>
-            <a:endParaRPr lang="he-IL"/>
-          </a:p>
-        </p:txBody>
-      </p:sp>
-      <p:pic>
-        <p:nvPicPr>
-          <p:cNvPr id="9" name="Picture 8">
-            <a:extLst>
-              <a:ext uri="{FF2B5EF4-FFF2-40B4-BE49-F238E27FC236}">
-                <a16:creationId xmlns:a16="http://schemas.microsoft.com/office/drawing/2014/main" id="{74FA35B5-148A-4935-0918-A1F0A76257E8}"/>
-              </a:ext>
-            </a:extLst>
-          </p:cNvPr>
-          <p:cNvPicPr>
-            <a:picLocks noChangeAspect="1"/>
-          </p:cNvPicPr>
-          <p:nvPr/>
-        </p:nvPicPr>
-        <p:blipFill>
-          <a:blip r:embed="rId2"/>
-          <a:stretch>
-            <a:fillRect/>
-          </a:stretch>
-        </p:blipFill>
-        <p:spPr>
-          <a:xfrm>
-            <a:off x="801849" y="870615"/>
-            <a:ext cx="10588302" cy="5462808"/>
-          </a:xfrm>
-          <a:prstGeom prst="rect">
-            <a:avLst/>
-          </a:prstGeom>
-        </p:spPr>
-      </p:pic>
-    </p:spTree>
-    <p:extLst>
-      <p:ext uri="{BB962C8B-B14F-4D97-AF65-F5344CB8AC3E}">
-        <p14:creationId xmlns:p14="http://schemas.microsoft.com/office/powerpoint/2010/main" val="3306335861"/>
-      </p:ext>
-    </p:extLst>
-  </p:cSld>
-  <p:clrMapOvr>
-    <a:masterClrMapping/>
-  </p:clrMapOvr>
-</p:sld>
-</file>
-
-<file path=ppt/slides/slide28.xml><?xml version="1.0" encoding="utf-8"?>
-<p:sld xmlns:a="http://schemas.openxmlformats.org/drawingml/2006/main" xmlns:r="http://schemas.openxmlformats.org/officeDocument/2006/relationships" xmlns:p="http://schemas.openxmlformats.org/presentationml/2006/main" show="0">
-  <p:cSld>
-    <p:spTree>
-      <p:nvGrpSpPr>
-        <p:cNvPr id="1" name="">
-          <a:extLst>
-            <a:ext uri="{FF2B5EF4-FFF2-40B4-BE49-F238E27FC236}">
-              <a16:creationId xmlns:a16="http://schemas.microsoft.com/office/drawing/2014/main" id="{FC57CEC8-F28B-AF96-D25C-C5077F7AD920}"/>
-            </a:ext>
-          </a:extLst>
-        </p:cNvPr>
-        <p:cNvGrpSpPr/>
-        <p:nvPr/>
-      </p:nvGrpSpPr>
-      <p:grpSpPr>
-        <a:xfrm>
-          <a:off x="0" y="0"/>
-          <a:ext cx="0" cy="0"/>
-          <a:chOff x="0" y="0"/>
-          <a:chExt cx="0" cy="0"/>
-        </a:xfrm>
-      </p:grpSpPr>
-      <p:sp>
-        <p:nvSpPr>
-          <p:cNvPr id="2" name="Title 1">
-            <a:extLst>
-              <a:ext uri="{FF2B5EF4-FFF2-40B4-BE49-F238E27FC236}">
-                <a16:creationId xmlns:a16="http://schemas.microsoft.com/office/drawing/2014/main" id="{7F3677C7-2976-BAF7-7BC0-B94298F56216}"/>
-              </a:ext>
-            </a:extLst>
-          </p:cNvPr>
-          <p:cNvSpPr>
-            <a:spLocks noGrp="1"/>
-          </p:cNvSpPr>
-          <p:nvPr>
-            <p:ph type="title"/>
-          </p:nvPr>
-        </p:nvSpPr>
-        <p:spPr>
-          <a:xfrm>
-            <a:off x="3427462" y="-55282"/>
-            <a:ext cx="8753475" cy="1325563"/>
-          </a:xfrm>
-        </p:spPr>
-        <p:txBody>
-          <a:bodyPr anchor="ctr">
-            <a:normAutofit/>
-          </a:bodyPr>
-          <a:lstStyle/>
-          <a:p>
-            <a:r>
-              <a:rPr lang="en-GB" dirty="0"/>
-              <a:t>K-Core Example - Top Posts</a:t>
-            </a:r>
-            <a:endParaRPr lang="en-IL" dirty="0"/>
-          </a:p>
-        </p:txBody>
-      </p:sp>
-      <p:sp>
-        <p:nvSpPr>
-          <p:cNvPr id="4" name="Slide Number Placeholder 3">
-            <a:extLst>
-              <a:ext uri="{FF2B5EF4-FFF2-40B4-BE49-F238E27FC236}">
-                <a16:creationId xmlns:a16="http://schemas.microsoft.com/office/drawing/2014/main" id="{A4ACD51B-F403-C5B4-93EF-0481AFDB3BE6}"/>
-              </a:ext>
-            </a:extLst>
-          </p:cNvPr>
-          <p:cNvSpPr>
-            <a:spLocks noGrp="1"/>
-          </p:cNvSpPr>
-          <p:nvPr>
-            <p:ph type="sldNum" sz="quarter" idx="12"/>
-          </p:nvPr>
-        </p:nvSpPr>
-        <p:spPr>
-          <a:xfrm>
-            <a:off x="11728704" y="6464649"/>
-            <a:ext cx="452233" cy="365125"/>
-          </a:xfrm>
-        </p:spPr>
-        <p:txBody>
-          <a:bodyPr anchor="ctr">
-            <a:normAutofit/>
-          </a:bodyPr>
-          <a:lstStyle/>
-          <a:p>
-            <a:pPr>
-              <a:spcAft>
-                <a:spcPts val="600"/>
-              </a:spcAft>
-            </a:pPr>
-            <a:fld id="{E6AB8EDD-9EF2-4633-A1C2-4D908C1019B4}" type="slidenum">
-              <a:rPr lang="he-IL" smtClean="0"/>
-              <a:pPr>
-                <a:spcAft>
-                  <a:spcPts val="600"/>
-                </a:spcAft>
-              </a:pPr>
-              <a:t>28</a:t>
-            </a:fld>
-            <a:endParaRPr lang="he-IL"/>
-          </a:p>
-        </p:txBody>
-      </p:sp>
-      <p:pic>
-        <p:nvPicPr>
-          <p:cNvPr id="5" name="Picture 4">
-            <a:extLst>
-              <a:ext uri="{FF2B5EF4-FFF2-40B4-BE49-F238E27FC236}">
-                <a16:creationId xmlns:a16="http://schemas.microsoft.com/office/drawing/2014/main" id="{BE02696E-EA6C-CB4E-05BF-C2B2F127F962}"/>
-              </a:ext>
-            </a:extLst>
-          </p:cNvPr>
-          <p:cNvPicPr>
-            <a:picLocks noChangeAspect="1"/>
-          </p:cNvPicPr>
-          <p:nvPr/>
-        </p:nvPicPr>
-        <p:blipFill>
-          <a:blip r:embed="rId2"/>
-          <a:stretch>
-            <a:fillRect/>
-          </a:stretch>
-        </p:blipFill>
-        <p:spPr>
-          <a:xfrm>
-            <a:off x="912064" y="1925054"/>
-            <a:ext cx="11083755" cy="3582270"/>
-          </a:xfrm>
-          <a:prstGeom prst="rect">
-            <a:avLst/>
-          </a:prstGeom>
-        </p:spPr>
-      </p:pic>
-    </p:spTree>
-    <p:extLst>
-      <p:ext uri="{BB962C8B-B14F-4D97-AF65-F5344CB8AC3E}">
-        <p14:creationId xmlns:p14="http://schemas.microsoft.com/office/powerpoint/2010/main" val="2089302828"/>
       </p:ext>
     </p:extLst>
   </p:cSld>

</xml_diff>